<commit_message>
archivo 1.5 terminado y base de PPT terminado
</commit_message>
<xml_diff>
--- a/Aldo Alberto Martinez Ordenes/PTY4614_Capstone_004D/Equipo/Fase 1/Evidencias Grupales/Presentación EventApp.pptx
+++ b/Aldo Alberto Martinez Ordenes/PTY4614_Capstone_004D/Equipo/Fase 1/Evidencias Grupales/Presentación EventApp.pptx
@@ -7,6 +7,16 @@
   <p:sldIdLst>
     <p:sldId id="256" r:id="rId2"/>
     <p:sldId id="257" r:id="rId3"/>
+    <p:sldId id="258" r:id="rId4"/>
+    <p:sldId id="259" r:id="rId5"/>
+    <p:sldId id="260" r:id="rId6"/>
+    <p:sldId id="261" r:id="rId7"/>
+    <p:sldId id="262" r:id="rId8"/>
+    <p:sldId id="263" r:id="rId9"/>
+    <p:sldId id="264" r:id="rId10"/>
+    <p:sldId id="265" r:id="rId11"/>
+    <p:sldId id="266" r:id="rId12"/>
+    <p:sldId id="268" r:id="rId13"/>
   </p:sldIdLst>
   <p:sldSz cx="12192000" cy="6858000"/>
   <p:notesSz cx="6858000" cy="9144000"/>
@@ -2935,7 +2945,7 @@
           <a:lstStyle/>
           <a:p>
             <a:r>
-              <a:rPr lang="es-MX" dirty="0" err="1">
+              <a:rPr lang="es-MX" dirty="0">
                 <a:solidFill>
                   <a:schemeClr val="accent1"/>
                 </a:solidFill>
@@ -2969,18 +2979,21 @@
         <p:spPr>
           <a:xfrm>
             <a:off x="1524000" y="2447553"/>
-            <a:ext cx="9144000" cy="1655762"/>
+            <a:ext cx="9144000" cy="445502"/>
           </a:xfrm>
         </p:spPr>
         <p:txBody>
           <a:bodyPr/>
           <a:lstStyle/>
           <a:p>
-            <a:endParaRPr lang="es-CL" dirty="0">
-              <a:solidFill>
-                <a:schemeClr val="accent1"/>
-              </a:solidFill>
-            </a:endParaRPr>
+            <a:r>
+              <a:rPr lang="es-CL" dirty="0">
+                <a:solidFill>
+                  <a:schemeClr val="accent1"/>
+                </a:solidFill>
+              </a:rPr>
+              <a:t>Proyecto app móvil para eventos cercanos</a:t>
+            </a:r>
           </a:p>
         </p:txBody>
       </p:sp>
@@ -3376,10 +3389,1101 @@
           </p:style>
         </p:cxnSp>
       </p:grpSp>
+      <p:sp>
+        <p:nvSpPr>
+          <p:cNvPr id="7" name="CuadroTexto 6">
+            <a:extLst>
+              <a:ext uri="{FF2B5EF4-FFF2-40B4-BE49-F238E27FC236}">
+                <a16:creationId xmlns:a16="http://schemas.microsoft.com/office/drawing/2014/main" id="{829C1F1E-759E-FA34-3C5B-F9C8AFAAC381}"/>
+              </a:ext>
+            </a:extLst>
+          </p:cNvPr>
+          <p:cNvSpPr txBox="1"/>
+          <p:nvPr/>
+        </p:nvSpPr>
+        <p:spPr>
+          <a:xfrm>
+            <a:off x="743483" y="4374703"/>
+            <a:ext cx="5443669" cy="1815882"/>
+          </a:xfrm>
+          <a:prstGeom prst="rect">
+            <a:avLst/>
+          </a:prstGeom>
+          <a:noFill/>
+        </p:spPr>
+        <p:txBody>
+          <a:bodyPr wrap="square" rtlCol="0" anchor="ctr">
+            <a:spAutoFit/>
+          </a:bodyPr>
+          <a:lstStyle/>
+          <a:p>
+            <a:r>
+              <a:rPr lang="es-MX" sz="1400" dirty="0">
+                <a:solidFill>
+                  <a:schemeClr val="bg1"/>
+                </a:solidFill>
+              </a:rPr>
+              <a:t>Integrantes:</a:t>
+            </a:r>
+          </a:p>
+          <a:p>
+            <a:pPr marL="285750" indent="-285750">
+              <a:buFontTx/>
+              <a:buChar char="-"/>
+            </a:pPr>
+            <a:r>
+              <a:rPr lang="es-MX" sz="1400" dirty="0">
+                <a:solidFill>
+                  <a:schemeClr val="bg1"/>
+                </a:solidFill>
+              </a:rPr>
+              <a:t>Benjamín Díaz</a:t>
+            </a:r>
+          </a:p>
+          <a:p>
+            <a:pPr marL="285750" indent="-285750">
+              <a:buFontTx/>
+              <a:buChar char="-"/>
+            </a:pPr>
+            <a:r>
+              <a:rPr lang="es-MX" sz="1400" dirty="0">
+                <a:solidFill>
+                  <a:schemeClr val="bg1"/>
+                </a:solidFill>
+              </a:rPr>
+              <a:t>Iñaki Fernández</a:t>
+            </a:r>
+          </a:p>
+          <a:p>
+            <a:pPr marL="285750" indent="-285750">
+              <a:buFontTx/>
+              <a:buChar char="-"/>
+            </a:pPr>
+            <a:r>
+              <a:rPr lang="es-MX" sz="1400" dirty="0">
+                <a:solidFill>
+                  <a:schemeClr val="bg1"/>
+                </a:solidFill>
+              </a:rPr>
+              <a:t>Benjamín Vargas</a:t>
+            </a:r>
+          </a:p>
+          <a:p>
+            <a:endParaRPr lang="es-MX" sz="1400" dirty="0">
+              <a:solidFill>
+                <a:schemeClr val="bg1"/>
+              </a:solidFill>
+            </a:endParaRPr>
+          </a:p>
+          <a:p>
+            <a:r>
+              <a:rPr lang="es-MX" sz="1400" dirty="0">
+                <a:solidFill>
+                  <a:schemeClr val="bg1"/>
+                </a:solidFill>
+              </a:rPr>
+              <a:t>Capstone_004D</a:t>
+            </a:r>
+          </a:p>
+          <a:p>
+            <a:r>
+              <a:rPr lang="es-MX" sz="1400" dirty="0">
+                <a:solidFill>
+                  <a:schemeClr val="bg1"/>
+                </a:solidFill>
+              </a:rPr>
+              <a:t>Docente: </a:t>
+            </a:r>
+            <a:r>
+              <a:rPr lang="es-CL" sz="1400" dirty="0">
+                <a:solidFill>
+                  <a:schemeClr val="bg1"/>
+                </a:solidFill>
+              </a:rPr>
+              <a:t>ALDO ALBERTO MARTINEZ ORDENES</a:t>
+            </a:r>
+          </a:p>
+          <a:p>
+            <a:endParaRPr lang="es-CL" sz="1400" dirty="0">
+              <a:solidFill>
+                <a:schemeClr val="bg1"/>
+              </a:solidFill>
+            </a:endParaRPr>
+          </a:p>
+        </p:txBody>
+      </p:sp>
     </p:spTree>
     <p:extLst>
       <p:ext uri="{BB962C8B-B14F-4D97-AF65-F5344CB8AC3E}">
         <p14:creationId xmlns:p14="http://schemas.microsoft.com/office/powerpoint/2010/main" val="1556653329"/>
+      </p:ext>
+    </p:extLst>
+  </p:cSld>
+  <p:clrMapOvr>
+    <a:masterClrMapping/>
+  </p:clrMapOvr>
+</p:sld>
+</file>
+
+<file path=ppt/slides/slide10.xml><?xml version="1.0" encoding="utf-8"?>
+<p:sld xmlns:a="http://schemas.openxmlformats.org/drawingml/2006/main" xmlns:r="http://schemas.openxmlformats.org/officeDocument/2006/relationships" xmlns:p="http://schemas.openxmlformats.org/presentationml/2006/main">
+  <p:cSld>
+    <p:bg>
+      <p:bgPr>
+        <a:solidFill>
+          <a:schemeClr val="tx2"/>
+        </a:solidFill>
+        <a:effectLst/>
+      </p:bgPr>
+    </p:bg>
+    <p:spTree>
+      <p:nvGrpSpPr>
+        <p:cNvPr id="1" name="">
+          <a:extLst>
+            <a:ext uri="{FF2B5EF4-FFF2-40B4-BE49-F238E27FC236}">
+              <a16:creationId xmlns:a16="http://schemas.microsoft.com/office/drawing/2014/main" id="{E2474F52-F80C-9A7A-5152-D89A5F373266}"/>
+            </a:ext>
+          </a:extLst>
+        </p:cNvPr>
+        <p:cNvGrpSpPr/>
+        <p:nvPr/>
+      </p:nvGrpSpPr>
+      <p:grpSpPr>
+        <a:xfrm>
+          <a:off x="0" y="0"/>
+          <a:ext cx="0" cy="0"/>
+          <a:chOff x="0" y="0"/>
+          <a:chExt cx="0" cy="0"/>
+        </a:xfrm>
+      </p:grpSpPr>
+      <p:sp>
+        <p:nvSpPr>
+          <p:cNvPr id="8" name="CuadroTexto 7">
+            <a:extLst>
+              <a:ext uri="{FF2B5EF4-FFF2-40B4-BE49-F238E27FC236}">
+                <a16:creationId xmlns:a16="http://schemas.microsoft.com/office/drawing/2014/main" id="{4AA918F1-82FF-B5D1-5CE9-308B16E55A6B}"/>
+              </a:ext>
+            </a:extLst>
+          </p:cNvPr>
+          <p:cNvSpPr txBox="1"/>
+          <p:nvPr/>
+        </p:nvSpPr>
+        <p:spPr>
+          <a:xfrm>
+            <a:off x="2281727" y="2264635"/>
+            <a:ext cx="4349810" cy="2346540"/>
+          </a:xfrm>
+          <a:prstGeom prst="rect">
+            <a:avLst/>
+          </a:prstGeom>
+          <a:noFill/>
+        </p:spPr>
+        <p:txBody>
+          <a:bodyPr wrap="square" rtlCol="0">
+            <a:spAutoFit/>
+          </a:bodyPr>
+          <a:lstStyle/>
+          <a:p>
+            <a:pPr marL="285750" indent="-285750">
+              <a:lnSpc>
+                <a:spcPct val="150000"/>
+              </a:lnSpc>
+              <a:buFont typeface="Arial" panose="020B0604020202020204" pitchFamily="34" charset="0"/>
+              <a:buChar char="•"/>
+            </a:pPr>
+            <a:r>
+              <a:rPr lang="es-MX" sz="2000" dirty="0" err="1">
+                <a:solidFill>
+                  <a:schemeClr val="bg1"/>
+                </a:solidFill>
+              </a:rPr>
+              <a:t>Saf</a:t>
+            </a:r>
+            <a:endParaRPr lang="es-MX" sz="2000" dirty="0">
+              <a:solidFill>
+                <a:schemeClr val="bg1"/>
+              </a:solidFill>
+            </a:endParaRPr>
+          </a:p>
+          <a:p>
+            <a:pPr marL="285750" indent="-285750">
+              <a:lnSpc>
+                <a:spcPct val="150000"/>
+              </a:lnSpc>
+              <a:buFont typeface="Arial" panose="020B0604020202020204" pitchFamily="34" charset="0"/>
+              <a:buChar char="•"/>
+            </a:pPr>
+            <a:endParaRPr lang="es-CL" sz="2000" dirty="0">
+              <a:solidFill>
+                <a:schemeClr val="bg1"/>
+              </a:solidFill>
+            </a:endParaRPr>
+          </a:p>
+          <a:p>
+            <a:pPr marL="285750" indent="-285750">
+              <a:lnSpc>
+                <a:spcPct val="150000"/>
+              </a:lnSpc>
+              <a:buFont typeface="Arial" panose="020B0604020202020204" pitchFamily="34" charset="0"/>
+              <a:buChar char="•"/>
+            </a:pPr>
+            <a:r>
+              <a:rPr lang="es-CL" sz="2000" dirty="0">
+                <a:solidFill>
+                  <a:schemeClr val="bg1"/>
+                </a:solidFill>
+              </a:rPr>
+              <a:t>S</a:t>
+            </a:r>
+          </a:p>
+          <a:p>
+            <a:pPr marL="285750" indent="-285750">
+              <a:lnSpc>
+                <a:spcPct val="150000"/>
+              </a:lnSpc>
+              <a:buFont typeface="Arial" panose="020B0604020202020204" pitchFamily="34" charset="0"/>
+              <a:buChar char="•"/>
+            </a:pPr>
+            <a:endParaRPr lang="es-CL" sz="2000" dirty="0">
+              <a:solidFill>
+                <a:schemeClr val="bg1"/>
+              </a:solidFill>
+            </a:endParaRPr>
+          </a:p>
+          <a:p>
+            <a:pPr marL="285750" indent="-285750">
+              <a:lnSpc>
+                <a:spcPct val="150000"/>
+              </a:lnSpc>
+              <a:buFont typeface="Arial" panose="020B0604020202020204" pitchFamily="34" charset="0"/>
+              <a:buChar char="•"/>
+            </a:pPr>
+            <a:r>
+              <a:rPr lang="es-CL" sz="2000" dirty="0">
+                <a:solidFill>
+                  <a:schemeClr val="bg1"/>
+                </a:solidFill>
+              </a:rPr>
+              <a:t>s</a:t>
+            </a:r>
+            <a:endParaRPr lang="es-MX" sz="2000" dirty="0">
+              <a:solidFill>
+                <a:schemeClr val="bg1"/>
+              </a:solidFill>
+            </a:endParaRPr>
+          </a:p>
+        </p:txBody>
+      </p:sp>
+      <p:grpSp>
+        <p:nvGrpSpPr>
+          <p:cNvPr id="25" name="Grupo 24">
+            <a:extLst>
+              <a:ext uri="{FF2B5EF4-FFF2-40B4-BE49-F238E27FC236}">
+                <a16:creationId xmlns:a16="http://schemas.microsoft.com/office/drawing/2014/main" id="{AE0DEEA6-6BE8-12D1-5592-D3B27CFACED7}"/>
+              </a:ext>
+            </a:extLst>
+          </p:cNvPr>
+          <p:cNvGrpSpPr/>
+          <p:nvPr/>
+        </p:nvGrpSpPr>
+        <p:grpSpPr>
+          <a:xfrm>
+            <a:off x="841727" y="546930"/>
+            <a:ext cx="2880000" cy="540000"/>
+            <a:chOff x="786213" y="521293"/>
+            <a:chExt cx="2880000" cy="540000"/>
+          </a:xfrm>
+        </p:grpSpPr>
+        <p:cxnSp>
+          <p:nvCxnSpPr>
+            <p:cNvPr id="10" name="Conector recto 9">
+              <a:extLst>
+                <a:ext uri="{FF2B5EF4-FFF2-40B4-BE49-F238E27FC236}">
+                  <a16:creationId xmlns:a16="http://schemas.microsoft.com/office/drawing/2014/main" id="{032AC6CA-C53A-5493-154E-37F392B6BC78}"/>
+                </a:ext>
+              </a:extLst>
+            </p:cNvPr>
+            <p:cNvCxnSpPr/>
+            <p:nvPr/>
+          </p:nvCxnSpPr>
+          <p:spPr>
+            <a:xfrm>
+              <a:off x="786213" y="521293"/>
+              <a:ext cx="0" cy="540000"/>
+            </a:xfrm>
+            <a:prstGeom prst="line">
+              <a:avLst/>
+            </a:prstGeom>
+          </p:spPr>
+          <p:style>
+            <a:lnRef idx="3">
+              <a:schemeClr val="accent2"/>
+            </a:lnRef>
+            <a:fillRef idx="0">
+              <a:schemeClr val="accent2"/>
+            </a:fillRef>
+            <a:effectRef idx="2">
+              <a:schemeClr val="accent2"/>
+            </a:effectRef>
+            <a:fontRef idx="minor">
+              <a:schemeClr val="tx1"/>
+            </a:fontRef>
+          </p:style>
+        </p:cxnSp>
+        <p:cxnSp>
+          <p:nvCxnSpPr>
+            <p:cNvPr id="14" name="Conector recto 13">
+              <a:extLst>
+                <a:ext uri="{FF2B5EF4-FFF2-40B4-BE49-F238E27FC236}">
+                  <a16:creationId xmlns:a16="http://schemas.microsoft.com/office/drawing/2014/main" id="{22D99637-052D-9D8B-8A3F-5FC678DD9E65}"/>
+                </a:ext>
+              </a:extLst>
+            </p:cNvPr>
+            <p:cNvCxnSpPr>
+              <a:cxnSpLocks/>
+            </p:cNvCxnSpPr>
+            <p:nvPr/>
+          </p:nvCxnSpPr>
+          <p:spPr>
+            <a:xfrm>
+              <a:off x="786213" y="1061293"/>
+              <a:ext cx="2880000" cy="0"/>
+            </a:xfrm>
+            <a:prstGeom prst="line">
+              <a:avLst/>
+            </a:prstGeom>
+          </p:spPr>
+          <p:style>
+            <a:lnRef idx="3">
+              <a:schemeClr val="accent2"/>
+            </a:lnRef>
+            <a:fillRef idx="0">
+              <a:schemeClr val="accent2"/>
+            </a:fillRef>
+            <a:effectRef idx="2">
+              <a:schemeClr val="accent2"/>
+            </a:effectRef>
+            <a:fontRef idx="minor">
+              <a:schemeClr val="tx1"/>
+            </a:fontRef>
+          </p:style>
+        </p:cxnSp>
+      </p:grpSp>
+      <p:sp>
+        <p:nvSpPr>
+          <p:cNvPr id="3" name="CuadroTexto 2">
+            <a:extLst>
+              <a:ext uri="{FF2B5EF4-FFF2-40B4-BE49-F238E27FC236}">
+                <a16:creationId xmlns:a16="http://schemas.microsoft.com/office/drawing/2014/main" id="{B7EFF28F-B004-F7B6-F346-79049DEC0080}"/>
+              </a:ext>
+            </a:extLst>
+          </p:cNvPr>
+          <p:cNvSpPr txBox="1"/>
+          <p:nvPr/>
+        </p:nvSpPr>
+        <p:spPr>
+          <a:xfrm>
+            <a:off x="1031888" y="555724"/>
+            <a:ext cx="2499678" cy="369332"/>
+          </a:xfrm>
+          <a:prstGeom prst="rect">
+            <a:avLst/>
+          </a:prstGeom>
+          <a:noFill/>
+        </p:spPr>
+        <p:txBody>
+          <a:bodyPr wrap="square" rtlCol="0">
+            <a:spAutoFit/>
+          </a:bodyPr>
+          <a:lstStyle/>
+          <a:p>
+            <a:r>
+              <a:rPr lang="es-MX" dirty="0">
+                <a:solidFill>
+                  <a:schemeClr val="accent1"/>
+                </a:solidFill>
+                <a:latin typeface="+mj-lt"/>
+              </a:rPr>
+              <a:t>Riesgos</a:t>
+            </a:r>
+            <a:endParaRPr lang="es-CL" dirty="0">
+              <a:solidFill>
+                <a:schemeClr val="accent1"/>
+              </a:solidFill>
+              <a:latin typeface="+mj-lt"/>
+            </a:endParaRPr>
+          </a:p>
+        </p:txBody>
+      </p:sp>
+    </p:spTree>
+    <p:extLst>
+      <p:ext uri="{BB962C8B-B14F-4D97-AF65-F5344CB8AC3E}">
+        <p14:creationId xmlns:p14="http://schemas.microsoft.com/office/powerpoint/2010/main" val="1744374417"/>
+      </p:ext>
+    </p:extLst>
+  </p:cSld>
+  <p:clrMapOvr>
+    <a:masterClrMapping/>
+  </p:clrMapOvr>
+</p:sld>
+</file>
+
+<file path=ppt/slides/slide11.xml><?xml version="1.0" encoding="utf-8"?>
+<p:sld xmlns:a="http://schemas.openxmlformats.org/drawingml/2006/main" xmlns:r="http://schemas.openxmlformats.org/officeDocument/2006/relationships" xmlns:p="http://schemas.openxmlformats.org/presentationml/2006/main">
+  <p:cSld>
+    <p:bg>
+      <p:bgPr>
+        <a:solidFill>
+          <a:schemeClr val="tx2"/>
+        </a:solidFill>
+        <a:effectLst/>
+      </p:bgPr>
+    </p:bg>
+    <p:spTree>
+      <p:nvGrpSpPr>
+        <p:cNvPr id="1" name="">
+          <a:extLst>
+            <a:ext uri="{FF2B5EF4-FFF2-40B4-BE49-F238E27FC236}">
+              <a16:creationId xmlns:a16="http://schemas.microsoft.com/office/drawing/2014/main" id="{C9DD825B-358F-A2CE-A250-7CEE3EDF36A9}"/>
+            </a:ext>
+          </a:extLst>
+        </p:cNvPr>
+        <p:cNvGrpSpPr/>
+        <p:nvPr/>
+      </p:nvGrpSpPr>
+      <p:grpSpPr>
+        <a:xfrm>
+          <a:off x="0" y="0"/>
+          <a:ext cx="0" cy="0"/>
+          <a:chOff x="0" y="0"/>
+          <a:chExt cx="0" cy="0"/>
+        </a:xfrm>
+      </p:grpSpPr>
+      <p:grpSp>
+        <p:nvGrpSpPr>
+          <p:cNvPr id="25" name="Grupo 24">
+            <a:extLst>
+              <a:ext uri="{FF2B5EF4-FFF2-40B4-BE49-F238E27FC236}">
+                <a16:creationId xmlns:a16="http://schemas.microsoft.com/office/drawing/2014/main" id="{3F496617-0BEE-4BF7-6A40-8117DD9B74C6}"/>
+              </a:ext>
+            </a:extLst>
+          </p:cNvPr>
+          <p:cNvGrpSpPr/>
+          <p:nvPr/>
+        </p:nvGrpSpPr>
+        <p:grpSpPr>
+          <a:xfrm>
+            <a:off x="841727" y="546930"/>
+            <a:ext cx="2880000" cy="540000"/>
+            <a:chOff x="786213" y="521293"/>
+            <a:chExt cx="2880000" cy="540000"/>
+          </a:xfrm>
+        </p:grpSpPr>
+        <p:cxnSp>
+          <p:nvCxnSpPr>
+            <p:cNvPr id="10" name="Conector recto 9">
+              <a:extLst>
+                <a:ext uri="{FF2B5EF4-FFF2-40B4-BE49-F238E27FC236}">
+                  <a16:creationId xmlns:a16="http://schemas.microsoft.com/office/drawing/2014/main" id="{B89DF86A-4D6B-761A-5F37-4993F134A769}"/>
+                </a:ext>
+              </a:extLst>
+            </p:cNvPr>
+            <p:cNvCxnSpPr/>
+            <p:nvPr/>
+          </p:nvCxnSpPr>
+          <p:spPr>
+            <a:xfrm>
+              <a:off x="786213" y="521293"/>
+              <a:ext cx="0" cy="540000"/>
+            </a:xfrm>
+            <a:prstGeom prst="line">
+              <a:avLst/>
+            </a:prstGeom>
+          </p:spPr>
+          <p:style>
+            <a:lnRef idx="3">
+              <a:schemeClr val="accent2"/>
+            </a:lnRef>
+            <a:fillRef idx="0">
+              <a:schemeClr val="accent2"/>
+            </a:fillRef>
+            <a:effectRef idx="2">
+              <a:schemeClr val="accent2"/>
+            </a:effectRef>
+            <a:fontRef idx="minor">
+              <a:schemeClr val="tx1"/>
+            </a:fontRef>
+          </p:style>
+        </p:cxnSp>
+        <p:cxnSp>
+          <p:nvCxnSpPr>
+            <p:cNvPr id="14" name="Conector recto 13">
+              <a:extLst>
+                <a:ext uri="{FF2B5EF4-FFF2-40B4-BE49-F238E27FC236}">
+                  <a16:creationId xmlns:a16="http://schemas.microsoft.com/office/drawing/2014/main" id="{6EF7597D-2A65-90CE-3D62-FBC24A092902}"/>
+                </a:ext>
+              </a:extLst>
+            </p:cNvPr>
+            <p:cNvCxnSpPr>
+              <a:cxnSpLocks/>
+            </p:cNvCxnSpPr>
+            <p:nvPr/>
+          </p:nvCxnSpPr>
+          <p:spPr>
+            <a:xfrm>
+              <a:off x="786213" y="1061293"/>
+              <a:ext cx="2880000" cy="0"/>
+            </a:xfrm>
+            <a:prstGeom prst="line">
+              <a:avLst/>
+            </a:prstGeom>
+          </p:spPr>
+          <p:style>
+            <a:lnRef idx="3">
+              <a:schemeClr val="accent2"/>
+            </a:lnRef>
+            <a:fillRef idx="0">
+              <a:schemeClr val="accent2"/>
+            </a:fillRef>
+            <a:effectRef idx="2">
+              <a:schemeClr val="accent2"/>
+            </a:effectRef>
+            <a:fontRef idx="minor">
+              <a:schemeClr val="tx1"/>
+            </a:fontRef>
+          </p:style>
+        </p:cxnSp>
+      </p:grpSp>
+      <p:sp>
+        <p:nvSpPr>
+          <p:cNvPr id="3" name="CuadroTexto 2">
+            <a:extLst>
+              <a:ext uri="{FF2B5EF4-FFF2-40B4-BE49-F238E27FC236}">
+                <a16:creationId xmlns:a16="http://schemas.microsoft.com/office/drawing/2014/main" id="{C787C829-A612-8ECC-0E31-797BE398CEFB}"/>
+              </a:ext>
+            </a:extLst>
+          </p:cNvPr>
+          <p:cNvSpPr txBox="1"/>
+          <p:nvPr/>
+        </p:nvSpPr>
+        <p:spPr>
+          <a:xfrm>
+            <a:off x="1031888" y="555724"/>
+            <a:ext cx="2499678" cy="369332"/>
+          </a:xfrm>
+          <a:prstGeom prst="rect">
+            <a:avLst/>
+          </a:prstGeom>
+          <a:noFill/>
+        </p:spPr>
+        <p:txBody>
+          <a:bodyPr wrap="square" rtlCol="0">
+            <a:spAutoFit/>
+          </a:bodyPr>
+          <a:lstStyle/>
+          <a:p>
+            <a:r>
+              <a:rPr lang="es-MX" dirty="0">
+                <a:solidFill>
+                  <a:schemeClr val="accent1"/>
+                </a:solidFill>
+                <a:latin typeface="+mj-lt"/>
+              </a:rPr>
+              <a:t>Mockup</a:t>
+            </a:r>
+            <a:endParaRPr lang="es-CL" dirty="0">
+              <a:solidFill>
+                <a:schemeClr val="accent1"/>
+              </a:solidFill>
+              <a:latin typeface="+mj-lt"/>
+            </a:endParaRPr>
+          </a:p>
+        </p:txBody>
+      </p:sp>
+    </p:spTree>
+    <p:extLst>
+      <p:ext uri="{BB962C8B-B14F-4D97-AF65-F5344CB8AC3E}">
+        <p14:creationId xmlns:p14="http://schemas.microsoft.com/office/powerpoint/2010/main" val="636617653"/>
+      </p:ext>
+    </p:extLst>
+  </p:cSld>
+  <p:clrMapOvr>
+    <a:masterClrMapping/>
+  </p:clrMapOvr>
+</p:sld>
+</file>
+
+<file path=ppt/slides/slide12.xml><?xml version="1.0" encoding="utf-8"?>
+<p:sld xmlns:a="http://schemas.openxmlformats.org/drawingml/2006/main" xmlns:r="http://schemas.openxmlformats.org/officeDocument/2006/relationships" xmlns:p="http://schemas.openxmlformats.org/presentationml/2006/main">
+  <p:cSld>
+    <p:bg>
+      <p:bgPr>
+        <a:solidFill>
+          <a:schemeClr val="tx2"/>
+        </a:solidFill>
+        <a:effectLst/>
+      </p:bgPr>
+    </p:bg>
+    <p:spTree>
+      <p:nvGrpSpPr>
+        <p:cNvPr id="1" name="">
+          <a:extLst>
+            <a:ext uri="{FF2B5EF4-FFF2-40B4-BE49-F238E27FC236}">
+              <a16:creationId xmlns:a16="http://schemas.microsoft.com/office/drawing/2014/main" id="{1724048F-0A51-1547-B1AC-CC69CED3A6C6}"/>
+            </a:ext>
+          </a:extLst>
+        </p:cNvPr>
+        <p:cNvGrpSpPr/>
+        <p:nvPr/>
+      </p:nvGrpSpPr>
+      <p:grpSpPr>
+        <a:xfrm>
+          <a:off x="0" y="0"/>
+          <a:ext cx="0" cy="0"/>
+          <a:chOff x="0" y="0"/>
+          <a:chExt cx="0" cy="0"/>
+        </a:xfrm>
+      </p:grpSpPr>
+      <p:sp>
+        <p:nvSpPr>
+          <p:cNvPr id="2" name="Título 1">
+            <a:extLst>
+              <a:ext uri="{FF2B5EF4-FFF2-40B4-BE49-F238E27FC236}">
+                <a16:creationId xmlns:a16="http://schemas.microsoft.com/office/drawing/2014/main" id="{113D8B02-7FDE-FD35-ECC3-F577360F7947}"/>
+              </a:ext>
+            </a:extLst>
+          </p:cNvPr>
+          <p:cNvSpPr>
+            <a:spLocks noGrp="1"/>
+          </p:cNvSpPr>
+          <p:nvPr>
+            <p:ph type="ctrTitle"/>
+          </p:nvPr>
+        </p:nvSpPr>
+        <p:spPr>
+          <a:xfrm>
+            <a:off x="1524000" y="2915774"/>
+            <a:ext cx="9144000" cy="1026452"/>
+          </a:xfrm>
+        </p:spPr>
+        <p:txBody>
+          <a:bodyPr>
+            <a:normAutofit/>
+          </a:bodyPr>
+          <a:lstStyle/>
+          <a:p>
+            <a:r>
+              <a:rPr lang="es-MX" dirty="0">
+                <a:solidFill>
+                  <a:schemeClr val="accent1"/>
+                </a:solidFill>
+              </a:rPr>
+              <a:t>Conclusión</a:t>
+            </a:r>
+            <a:endParaRPr lang="es-CL" dirty="0">
+              <a:solidFill>
+                <a:schemeClr val="accent1"/>
+              </a:solidFill>
+            </a:endParaRPr>
+          </a:p>
+        </p:txBody>
+      </p:sp>
+      <p:grpSp>
+        <p:nvGrpSpPr>
+          <p:cNvPr id="16" name="Grupo 15">
+            <a:extLst>
+              <a:ext uri="{FF2B5EF4-FFF2-40B4-BE49-F238E27FC236}">
+                <a16:creationId xmlns:a16="http://schemas.microsoft.com/office/drawing/2014/main" id="{8C3FB05D-F257-1453-9D11-FA3D82CB4972}"/>
+              </a:ext>
+            </a:extLst>
+          </p:cNvPr>
+          <p:cNvGrpSpPr/>
+          <p:nvPr/>
+        </p:nvGrpSpPr>
+        <p:grpSpPr>
+          <a:xfrm>
+            <a:off x="666571" y="555477"/>
+            <a:ext cx="1800000" cy="1800000"/>
+            <a:chOff x="666571" y="555477"/>
+            <a:chExt cx="1800000" cy="1800000"/>
+          </a:xfrm>
+        </p:grpSpPr>
+        <p:cxnSp>
+          <p:nvCxnSpPr>
+            <p:cNvPr id="5" name="Conector recto 4">
+              <a:extLst>
+                <a:ext uri="{FF2B5EF4-FFF2-40B4-BE49-F238E27FC236}">
+                  <a16:creationId xmlns:a16="http://schemas.microsoft.com/office/drawing/2014/main" id="{36AE21F0-9FA5-9C66-DF8C-F2CB0AE8F8CC}"/>
+                </a:ext>
+              </a:extLst>
+            </p:cNvPr>
+            <p:cNvCxnSpPr/>
+            <p:nvPr/>
+          </p:nvCxnSpPr>
+          <p:spPr>
+            <a:xfrm>
+              <a:off x="666571" y="555477"/>
+              <a:ext cx="1800000" cy="0"/>
+            </a:xfrm>
+            <a:prstGeom prst="line">
+              <a:avLst/>
+            </a:prstGeom>
+            <a:ln/>
+          </p:spPr>
+          <p:style>
+            <a:lnRef idx="3">
+              <a:schemeClr val="accent2"/>
+            </a:lnRef>
+            <a:fillRef idx="0">
+              <a:schemeClr val="accent2"/>
+            </a:fillRef>
+            <a:effectRef idx="2">
+              <a:schemeClr val="accent2"/>
+            </a:effectRef>
+            <a:fontRef idx="minor">
+              <a:schemeClr val="tx1"/>
+            </a:fontRef>
+          </p:style>
+        </p:cxnSp>
+        <p:cxnSp>
+          <p:nvCxnSpPr>
+            <p:cNvPr id="6" name="Conector recto 5">
+              <a:extLst>
+                <a:ext uri="{FF2B5EF4-FFF2-40B4-BE49-F238E27FC236}">
+                  <a16:creationId xmlns:a16="http://schemas.microsoft.com/office/drawing/2014/main" id="{C5B731D4-E085-520D-A716-6B4B86BC252F}"/>
+                </a:ext>
+              </a:extLst>
+            </p:cNvPr>
+            <p:cNvCxnSpPr>
+              <a:cxnSpLocks/>
+            </p:cNvCxnSpPr>
+            <p:nvPr/>
+          </p:nvCxnSpPr>
+          <p:spPr>
+            <a:xfrm flipV="1">
+              <a:off x="666572" y="555477"/>
+              <a:ext cx="0" cy="1800000"/>
+            </a:xfrm>
+            <a:prstGeom prst="line">
+              <a:avLst/>
+            </a:prstGeom>
+            <a:ln/>
+          </p:spPr>
+          <p:style>
+            <a:lnRef idx="3">
+              <a:schemeClr val="accent2"/>
+            </a:lnRef>
+            <a:fillRef idx="0">
+              <a:schemeClr val="accent2"/>
+            </a:fillRef>
+            <a:effectRef idx="2">
+              <a:schemeClr val="accent2"/>
+            </a:effectRef>
+            <a:fontRef idx="minor">
+              <a:schemeClr val="tx1"/>
+            </a:fontRef>
+          </p:style>
+        </p:cxnSp>
+      </p:grpSp>
+      <p:grpSp>
+        <p:nvGrpSpPr>
+          <p:cNvPr id="15" name="Grupo 14">
+            <a:extLst>
+              <a:ext uri="{FF2B5EF4-FFF2-40B4-BE49-F238E27FC236}">
+                <a16:creationId xmlns:a16="http://schemas.microsoft.com/office/drawing/2014/main" id="{97B0F812-76AD-768A-9542-98B0219854F7}"/>
+              </a:ext>
+            </a:extLst>
+          </p:cNvPr>
+          <p:cNvGrpSpPr/>
+          <p:nvPr/>
+        </p:nvGrpSpPr>
+        <p:grpSpPr>
+          <a:xfrm>
+            <a:off x="9725428" y="4484588"/>
+            <a:ext cx="1800000" cy="1800000"/>
+            <a:chOff x="9801881" y="4357800"/>
+            <a:chExt cx="1800000" cy="1800000"/>
+          </a:xfrm>
+        </p:grpSpPr>
+        <p:cxnSp>
+          <p:nvCxnSpPr>
+            <p:cNvPr id="11" name="Conector recto 10">
+              <a:extLst>
+                <a:ext uri="{FF2B5EF4-FFF2-40B4-BE49-F238E27FC236}">
+                  <a16:creationId xmlns:a16="http://schemas.microsoft.com/office/drawing/2014/main" id="{6D1331FC-6749-70FE-28A6-E3D51B36AA84}"/>
+                </a:ext>
+              </a:extLst>
+            </p:cNvPr>
+            <p:cNvCxnSpPr>
+              <a:cxnSpLocks/>
+            </p:cNvCxnSpPr>
+            <p:nvPr/>
+          </p:nvCxnSpPr>
+          <p:spPr>
+            <a:xfrm rot="5400000">
+              <a:off x="10701880" y="5257800"/>
+              <a:ext cx="1800000" cy="0"/>
+            </a:xfrm>
+            <a:prstGeom prst="line">
+              <a:avLst/>
+            </a:prstGeom>
+            <a:ln/>
+          </p:spPr>
+          <p:style>
+            <a:lnRef idx="3">
+              <a:schemeClr val="accent2"/>
+            </a:lnRef>
+            <a:fillRef idx="0">
+              <a:schemeClr val="accent2"/>
+            </a:fillRef>
+            <a:effectRef idx="2">
+              <a:schemeClr val="accent2"/>
+            </a:effectRef>
+            <a:fontRef idx="minor">
+              <a:schemeClr val="tx1"/>
+            </a:fontRef>
+          </p:style>
+        </p:cxnSp>
+        <p:cxnSp>
+          <p:nvCxnSpPr>
+            <p:cNvPr id="12" name="Conector recto 11">
+              <a:extLst>
+                <a:ext uri="{FF2B5EF4-FFF2-40B4-BE49-F238E27FC236}">
+                  <a16:creationId xmlns:a16="http://schemas.microsoft.com/office/drawing/2014/main" id="{05D9BC12-B1D8-3A66-F8A5-F4B275658ACF}"/>
+                </a:ext>
+              </a:extLst>
+            </p:cNvPr>
+            <p:cNvCxnSpPr>
+              <a:cxnSpLocks/>
+            </p:cNvCxnSpPr>
+            <p:nvPr/>
+          </p:nvCxnSpPr>
+          <p:spPr>
+            <a:xfrm rot="5400000" flipV="1">
+              <a:off x="10701881" y="5257800"/>
+              <a:ext cx="0" cy="1800000"/>
+            </a:xfrm>
+            <a:prstGeom prst="line">
+              <a:avLst/>
+            </a:prstGeom>
+            <a:ln/>
+          </p:spPr>
+          <p:style>
+            <a:lnRef idx="3">
+              <a:schemeClr val="accent2"/>
+            </a:lnRef>
+            <a:fillRef idx="0">
+              <a:schemeClr val="accent2"/>
+            </a:fillRef>
+            <a:effectRef idx="2">
+              <a:schemeClr val="accent2"/>
+            </a:effectRef>
+            <a:fontRef idx="minor">
+              <a:schemeClr val="tx1"/>
+            </a:fontRef>
+          </p:style>
+        </p:cxnSp>
+      </p:grpSp>
+      <p:grpSp>
+        <p:nvGrpSpPr>
+          <p:cNvPr id="17" name="Grupo 16">
+            <a:extLst>
+              <a:ext uri="{FF2B5EF4-FFF2-40B4-BE49-F238E27FC236}">
+                <a16:creationId xmlns:a16="http://schemas.microsoft.com/office/drawing/2014/main" id="{EAC00E75-E8EA-811C-33EF-0E7FA95B8195}"/>
+              </a:ext>
+            </a:extLst>
+          </p:cNvPr>
+          <p:cNvGrpSpPr/>
+          <p:nvPr/>
+        </p:nvGrpSpPr>
+        <p:grpSpPr>
+          <a:xfrm rot="16200000">
+            <a:off x="666571" y="4502524"/>
+            <a:ext cx="1800000" cy="1800000"/>
+            <a:chOff x="666571" y="555477"/>
+            <a:chExt cx="1800000" cy="1800000"/>
+          </a:xfrm>
+        </p:grpSpPr>
+        <p:cxnSp>
+          <p:nvCxnSpPr>
+            <p:cNvPr id="18" name="Conector recto 17">
+              <a:extLst>
+                <a:ext uri="{FF2B5EF4-FFF2-40B4-BE49-F238E27FC236}">
+                  <a16:creationId xmlns:a16="http://schemas.microsoft.com/office/drawing/2014/main" id="{AF6D210B-8735-DB71-071E-4FA9EAB077FC}"/>
+                </a:ext>
+              </a:extLst>
+            </p:cNvPr>
+            <p:cNvCxnSpPr/>
+            <p:nvPr/>
+          </p:nvCxnSpPr>
+          <p:spPr>
+            <a:xfrm>
+              <a:off x="666571" y="555477"/>
+              <a:ext cx="1800000" cy="0"/>
+            </a:xfrm>
+            <a:prstGeom prst="line">
+              <a:avLst/>
+            </a:prstGeom>
+            <a:ln/>
+          </p:spPr>
+          <p:style>
+            <a:lnRef idx="3">
+              <a:schemeClr val="accent2"/>
+            </a:lnRef>
+            <a:fillRef idx="0">
+              <a:schemeClr val="accent2"/>
+            </a:fillRef>
+            <a:effectRef idx="2">
+              <a:schemeClr val="accent2"/>
+            </a:effectRef>
+            <a:fontRef idx="minor">
+              <a:schemeClr val="tx1"/>
+            </a:fontRef>
+          </p:style>
+        </p:cxnSp>
+        <p:cxnSp>
+          <p:nvCxnSpPr>
+            <p:cNvPr id="19" name="Conector recto 18">
+              <a:extLst>
+                <a:ext uri="{FF2B5EF4-FFF2-40B4-BE49-F238E27FC236}">
+                  <a16:creationId xmlns:a16="http://schemas.microsoft.com/office/drawing/2014/main" id="{22647290-651A-5B82-D83E-FFFEA7BEA823}"/>
+                </a:ext>
+              </a:extLst>
+            </p:cNvPr>
+            <p:cNvCxnSpPr>
+              <a:cxnSpLocks/>
+            </p:cNvCxnSpPr>
+            <p:nvPr/>
+          </p:nvCxnSpPr>
+          <p:spPr>
+            <a:xfrm flipV="1">
+              <a:off x="666572" y="555477"/>
+              <a:ext cx="0" cy="1800000"/>
+            </a:xfrm>
+            <a:prstGeom prst="line">
+              <a:avLst/>
+            </a:prstGeom>
+            <a:ln/>
+          </p:spPr>
+          <p:style>
+            <a:lnRef idx="3">
+              <a:schemeClr val="accent2"/>
+            </a:lnRef>
+            <a:fillRef idx="0">
+              <a:schemeClr val="accent2"/>
+            </a:fillRef>
+            <a:effectRef idx="2">
+              <a:schemeClr val="accent2"/>
+            </a:effectRef>
+            <a:fontRef idx="minor">
+              <a:schemeClr val="tx1"/>
+            </a:fontRef>
+          </p:style>
+        </p:cxnSp>
+      </p:grpSp>
+      <p:grpSp>
+        <p:nvGrpSpPr>
+          <p:cNvPr id="20" name="Grupo 19">
+            <a:extLst>
+              <a:ext uri="{FF2B5EF4-FFF2-40B4-BE49-F238E27FC236}">
+                <a16:creationId xmlns:a16="http://schemas.microsoft.com/office/drawing/2014/main" id="{D6E56B9D-13A2-D158-6A09-D7F4B98FA047}"/>
+              </a:ext>
+            </a:extLst>
+          </p:cNvPr>
+          <p:cNvGrpSpPr/>
+          <p:nvPr/>
+        </p:nvGrpSpPr>
+        <p:grpSpPr>
+          <a:xfrm rot="16200000">
+            <a:off x="9725428" y="555477"/>
+            <a:ext cx="1800000" cy="1800000"/>
+            <a:chOff x="9801881" y="4357800"/>
+            <a:chExt cx="1800000" cy="1800000"/>
+          </a:xfrm>
+        </p:grpSpPr>
+        <p:cxnSp>
+          <p:nvCxnSpPr>
+            <p:cNvPr id="21" name="Conector recto 20">
+              <a:extLst>
+                <a:ext uri="{FF2B5EF4-FFF2-40B4-BE49-F238E27FC236}">
+                  <a16:creationId xmlns:a16="http://schemas.microsoft.com/office/drawing/2014/main" id="{24488377-5AC6-96C8-D400-03941F08FF00}"/>
+                </a:ext>
+              </a:extLst>
+            </p:cNvPr>
+            <p:cNvCxnSpPr>
+              <a:cxnSpLocks/>
+            </p:cNvCxnSpPr>
+            <p:nvPr/>
+          </p:nvCxnSpPr>
+          <p:spPr>
+            <a:xfrm rot="5400000">
+              <a:off x="10701880" y="5257800"/>
+              <a:ext cx="1800000" cy="0"/>
+            </a:xfrm>
+            <a:prstGeom prst="line">
+              <a:avLst/>
+            </a:prstGeom>
+            <a:ln/>
+          </p:spPr>
+          <p:style>
+            <a:lnRef idx="3">
+              <a:schemeClr val="accent2"/>
+            </a:lnRef>
+            <a:fillRef idx="0">
+              <a:schemeClr val="accent2"/>
+            </a:fillRef>
+            <a:effectRef idx="2">
+              <a:schemeClr val="accent2"/>
+            </a:effectRef>
+            <a:fontRef idx="minor">
+              <a:schemeClr val="tx1"/>
+            </a:fontRef>
+          </p:style>
+        </p:cxnSp>
+        <p:cxnSp>
+          <p:nvCxnSpPr>
+            <p:cNvPr id="22" name="Conector recto 21">
+              <a:extLst>
+                <a:ext uri="{FF2B5EF4-FFF2-40B4-BE49-F238E27FC236}">
+                  <a16:creationId xmlns:a16="http://schemas.microsoft.com/office/drawing/2014/main" id="{DB771FAC-5FE3-EE29-1F76-52B2EC14A990}"/>
+                </a:ext>
+              </a:extLst>
+            </p:cNvPr>
+            <p:cNvCxnSpPr>
+              <a:cxnSpLocks/>
+            </p:cNvCxnSpPr>
+            <p:nvPr/>
+          </p:nvCxnSpPr>
+          <p:spPr>
+            <a:xfrm rot="5400000" flipV="1">
+              <a:off x="10701881" y="5257800"/>
+              <a:ext cx="0" cy="1800000"/>
+            </a:xfrm>
+            <a:prstGeom prst="line">
+              <a:avLst/>
+            </a:prstGeom>
+            <a:ln/>
+          </p:spPr>
+          <p:style>
+            <a:lnRef idx="3">
+              <a:schemeClr val="accent2"/>
+            </a:lnRef>
+            <a:fillRef idx="0">
+              <a:schemeClr val="accent2"/>
+            </a:fillRef>
+            <a:effectRef idx="2">
+              <a:schemeClr val="accent2"/>
+            </a:effectRef>
+            <a:fontRef idx="minor">
+              <a:schemeClr val="tx1"/>
+            </a:fontRef>
+          </p:style>
+        </p:cxnSp>
+      </p:grpSp>
+    </p:spTree>
+    <p:extLst>
+      <p:ext uri="{BB962C8B-B14F-4D97-AF65-F5344CB8AC3E}">
+        <p14:creationId xmlns:p14="http://schemas.microsoft.com/office/powerpoint/2010/main" val="3203620280"/>
       </p:ext>
     </p:extLst>
   </p:cSld>
@@ -3633,10 +4737,2059 @@
           </p:style>
         </p:cxnSp>
       </p:grpSp>
+      <p:sp>
+        <p:nvSpPr>
+          <p:cNvPr id="2" name="CuadroTexto 1">
+            <a:extLst>
+              <a:ext uri="{FF2B5EF4-FFF2-40B4-BE49-F238E27FC236}">
+                <a16:creationId xmlns:a16="http://schemas.microsoft.com/office/drawing/2014/main" id="{A52EA291-9314-4C35-B185-5C79AD8F90D0}"/>
+              </a:ext>
+            </a:extLst>
+          </p:cNvPr>
+          <p:cNvSpPr txBox="1"/>
+          <p:nvPr/>
+        </p:nvSpPr>
+        <p:spPr>
+          <a:xfrm>
+            <a:off x="1031888" y="555724"/>
+            <a:ext cx="2499678" cy="369332"/>
+          </a:xfrm>
+          <a:prstGeom prst="rect">
+            <a:avLst/>
+          </a:prstGeom>
+          <a:noFill/>
+        </p:spPr>
+        <p:txBody>
+          <a:bodyPr wrap="square" rtlCol="0">
+            <a:spAutoFit/>
+          </a:bodyPr>
+          <a:lstStyle/>
+          <a:p>
+            <a:r>
+              <a:rPr lang="es-MX" dirty="0">
+                <a:solidFill>
+                  <a:schemeClr val="accent1"/>
+                </a:solidFill>
+                <a:latin typeface="+mj-lt"/>
+              </a:rPr>
+              <a:t>Introducción</a:t>
+            </a:r>
+            <a:endParaRPr lang="es-CL" dirty="0">
+              <a:solidFill>
+                <a:schemeClr val="accent1"/>
+              </a:solidFill>
+              <a:latin typeface="+mj-lt"/>
+            </a:endParaRPr>
+          </a:p>
+        </p:txBody>
+      </p:sp>
     </p:spTree>
     <p:extLst>
       <p:ext uri="{BB962C8B-B14F-4D97-AF65-F5344CB8AC3E}">
         <p14:creationId xmlns:p14="http://schemas.microsoft.com/office/powerpoint/2010/main" val="2286011023"/>
+      </p:ext>
+    </p:extLst>
+  </p:cSld>
+  <p:clrMapOvr>
+    <a:masterClrMapping/>
+  </p:clrMapOvr>
+</p:sld>
+</file>
+
+<file path=ppt/slides/slide3.xml><?xml version="1.0" encoding="utf-8"?>
+<p:sld xmlns:a="http://schemas.openxmlformats.org/drawingml/2006/main" xmlns:r="http://schemas.openxmlformats.org/officeDocument/2006/relationships" xmlns:p="http://schemas.openxmlformats.org/presentationml/2006/main">
+  <p:cSld>
+    <p:bg>
+      <p:bgPr>
+        <a:solidFill>
+          <a:schemeClr val="tx2"/>
+        </a:solidFill>
+        <a:effectLst/>
+      </p:bgPr>
+    </p:bg>
+    <p:spTree>
+      <p:nvGrpSpPr>
+        <p:cNvPr id="1" name="">
+          <a:extLst>
+            <a:ext uri="{FF2B5EF4-FFF2-40B4-BE49-F238E27FC236}">
+              <a16:creationId xmlns:a16="http://schemas.microsoft.com/office/drawing/2014/main" id="{C540BD4A-40B1-A3B8-ABDA-4CC116E12B18}"/>
+            </a:ext>
+          </a:extLst>
+        </p:cNvPr>
+        <p:cNvGrpSpPr/>
+        <p:nvPr/>
+      </p:nvGrpSpPr>
+      <p:grpSpPr>
+        <a:xfrm>
+          <a:off x="0" y="0"/>
+          <a:ext cx="0" cy="0"/>
+          <a:chOff x="0" y="0"/>
+          <a:chExt cx="0" cy="0"/>
+        </a:xfrm>
+      </p:grpSpPr>
+      <p:sp>
+        <p:nvSpPr>
+          <p:cNvPr id="8" name="CuadroTexto 7">
+            <a:extLst>
+              <a:ext uri="{FF2B5EF4-FFF2-40B4-BE49-F238E27FC236}">
+                <a16:creationId xmlns:a16="http://schemas.microsoft.com/office/drawing/2014/main" id="{D697394C-3EB3-051E-BB3B-46414AC7ED3F}"/>
+              </a:ext>
+            </a:extLst>
+          </p:cNvPr>
+          <p:cNvSpPr txBox="1"/>
+          <p:nvPr/>
+        </p:nvSpPr>
+        <p:spPr>
+          <a:xfrm>
+            <a:off x="2281727" y="2264635"/>
+            <a:ext cx="4349810" cy="2346540"/>
+          </a:xfrm>
+          <a:prstGeom prst="rect">
+            <a:avLst/>
+          </a:prstGeom>
+          <a:noFill/>
+        </p:spPr>
+        <p:txBody>
+          <a:bodyPr wrap="square" rtlCol="0">
+            <a:spAutoFit/>
+          </a:bodyPr>
+          <a:lstStyle/>
+          <a:p>
+            <a:pPr marL="285750" indent="-285750">
+              <a:lnSpc>
+                <a:spcPct val="150000"/>
+              </a:lnSpc>
+              <a:buFont typeface="Arial" panose="020B0604020202020204" pitchFamily="34" charset="0"/>
+              <a:buChar char="•"/>
+            </a:pPr>
+            <a:r>
+              <a:rPr lang="es-MX" sz="2000" dirty="0" err="1">
+                <a:solidFill>
+                  <a:schemeClr val="bg1"/>
+                </a:solidFill>
+              </a:rPr>
+              <a:t>Saf</a:t>
+            </a:r>
+            <a:endParaRPr lang="es-MX" sz="2000" dirty="0">
+              <a:solidFill>
+                <a:schemeClr val="bg1"/>
+              </a:solidFill>
+            </a:endParaRPr>
+          </a:p>
+          <a:p>
+            <a:pPr marL="285750" indent="-285750">
+              <a:lnSpc>
+                <a:spcPct val="150000"/>
+              </a:lnSpc>
+              <a:buFont typeface="Arial" panose="020B0604020202020204" pitchFamily="34" charset="0"/>
+              <a:buChar char="•"/>
+            </a:pPr>
+            <a:endParaRPr lang="es-CL" sz="2000" dirty="0">
+              <a:solidFill>
+                <a:schemeClr val="bg1"/>
+              </a:solidFill>
+            </a:endParaRPr>
+          </a:p>
+          <a:p>
+            <a:pPr marL="285750" indent="-285750">
+              <a:lnSpc>
+                <a:spcPct val="150000"/>
+              </a:lnSpc>
+              <a:buFont typeface="Arial" panose="020B0604020202020204" pitchFamily="34" charset="0"/>
+              <a:buChar char="•"/>
+            </a:pPr>
+            <a:r>
+              <a:rPr lang="es-CL" sz="2000" dirty="0">
+                <a:solidFill>
+                  <a:schemeClr val="bg1"/>
+                </a:solidFill>
+              </a:rPr>
+              <a:t>S</a:t>
+            </a:r>
+          </a:p>
+          <a:p>
+            <a:pPr marL="285750" indent="-285750">
+              <a:lnSpc>
+                <a:spcPct val="150000"/>
+              </a:lnSpc>
+              <a:buFont typeface="Arial" panose="020B0604020202020204" pitchFamily="34" charset="0"/>
+              <a:buChar char="•"/>
+            </a:pPr>
+            <a:endParaRPr lang="es-CL" sz="2000" dirty="0">
+              <a:solidFill>
+                <a:schemeClr val="bg1"/>
+              </a:solidFill>
+            </a:endParaRPr>
+          </a:p>
+          <a:p>
+            <a:pPr marL="285750" indent="-285750">
+              <a:lnSpc>
+                <a:spcPct val="150000"/>
+              </a:lnSpc>
+              <a:buFont typeface="Arial" panose="020B0604020202020204" pitchFamily="34" charset="0"/>
+              <a:buChar char="•"/>
+            </a:pPr>
+            <a:r>
+              <a:rPr lang="es-CL" sz="2000" dirty="0">
+                <a:solidFill>
+                  <a:schemeClr val="bg1"/>
+                </a:solidFill>
+              </a:rPr>
+              <a:t>s</a:t>
+            </a:r>
+            <a:endParaRPr lang="es-MX" sz="2000" dirty="0">
+              <a:solidFill>
+                <a:schemeClr val="bg1"/>
+              </a:solidFill>
+            </a:endParaRPr>
+          </a:p>
+        </p:txBody>
+      </p:sp>
+      <p:grpSp>
+        <p:nvGrpSpPr>
+          <p:cNvPr id="25" name="Grupo 24">
+            <a:extLst>
+              <a:ext uri="{FF2B5EF4-FFF2-40B4-BE49-F238E27FC236}">
+                <a16:creationId xmlns:a16="http://schemas.microsoft.com/office/drawing/2014/main" id="{8F18C815-584E-60D6-D87B-F5489B7EEC3F}"/>
+              </a:ext>
+            </a:extLst>
+          </p:cNvPr>
+          <p:cNvGrpSpPr/>
+          <p:nvPr/>
+        </p:nvGrpSpPr>
+        <p:grpSpPr>
+          <a:xfrm>
+            <a:off x="841727" y="546930"/>
+            <a:ext cx="2880000" cy="540000"/>
+            <a:chOff x="786213" y="521293"/>
+            <a:chExt cx="2880000" cy="540000"/>
+          </a:xfrm>
+        </p:grpSpPr>
+        <p:cxnSp>
+          <p:nvCxnSpPr>
+            <p:cNvPr id="10" name="Conector recto 9">
+              <a:extLst>
+                <a:ext uri="{FF2B5EF4-FFF2-40B4-BE49-F238E27FC236}">
+                  <a16:creationId xmlns:a16="http://schemas.microsoft.com/office/drawing/2014/main" id="{4EBB4DEA-B4C9-22FB-0E84-B646F95232F4}"/>
+                </a:ext>
+              </a:extLst>
+            </p:cNvPr>
+            <p:cNvCxnSpPr/>
+            <p:nvPr/>
+          </p:nvCxnSpPr>
+          <p:spPr>
+            <a:xfrm>
+              <a:off x="786213" y="521293"/>
+              <a:ext cx="0" cy="540000"/>
+            </a:xfrm>
+            <a:prstGeom prst="line">
+              <a:avLst/>
+            </a:prstGeom>
+          </p:spPr>
+          <p:style>
+            <a:lnRef idx="3">
+              <a:schemeClr val="accent2"/>
+            </a:lnRef>
+            <a:fillRef idx="0">
+              <a:schemeClr val="accent2"/>
+            </a:fillRef>
+            <a:effectRef idx="2">
+              <a:schemeClr val="accent2"/>
+            </a:effectRef>
+            <a:fontRef idx="minor">
+              <a:schemeClr val="tx1"/>
+            </a:fontRef>
+          </p:style>
+        </p:cxnSp>
+        <p:cxnSp>
+          <p:nvCxnSpPr>
+            <p:cNvPr id="14" name="Conector recto 13">
+              <a:extLst>
+                <a:ext uri="{FF2B5EF4-FFF2-40B4-BE49-F238E27FC236}">
+                  <a16:creationId xmlns:a16="http://schemas.microsoft.com/office/drawing/2014/main" id="{7E3885E7-19E2-3DD2-08ED-5EB12021A7B0}"/>
+                </a:ext>
+              </a:extLst>
+            </p:cNvPr>
+            <p:cNvCxnSpPr>
+              <a:cxnSpLocks/>
+            </p:cNvCxnSpPr>
+            <p:nvPr/>
+          </p:nvCxnSpPr>
+          <p:spPr>
+            <a:xfrm>
+              <a:off x="786213" y="1061293"/>
+              <a:ext cx="2880000" cy="0"/>
+            </a:xfrm>
+            <a:prstGeom prst="line">
+              <a:avLst/>
+            </a:prstGeom>
+          </p:spPr>
+          <p:style>
+            <a:lnRef idx="3">
+              <a:schemeClr val="accent2"/>
+            </a:lnRef>
+            <a:fillRef idx="0">
+              <a:schemeClr val="accent2"/>
+            </a:fillRef>
+            <a:effectRef idx="2">
+              <a:schemeClr val="accent2"/>
+            </a:effectRef>
+            <a:fontRef idx="minor">
+              <a:schemeClr val="tx1"/>
+            </a:fontRef>
+          </p:style>
+        </p:cxnSp>
+      </p:grpSp>
+      <p:sp>
+        <p:nvSpPr>
+          <p:cNvPr id="3" name="CuadroTexto 2">
+            <a:extLst>
+              <a:ext uri="{FF2B5EF4-FFF2-40B4-BE49-F238E27FC236}">
+                <a16:creationId xmlns:a16="http://schemas.microsoft.com/office/drawing/2014/main" id="{F1EFD41A-FAFC-9BED-5C7C-5A2B46425529}"/>
+              </a:ext>
+            </a:extLst>
+          </p:cNvPr>
+          <p:cNvSpPr txBox="1"/>
+          <p:nvPr/>
+        </p:nvSpPr>
+        <p:spPr>
+          <a:xfrm>
+            <a:off x="1031888" y="555724"/>
+            <a:ext cx="2499678" cy="369332"/>
+          </a:xfrm>
+          <a:prstGeom prst="rect">
+            <a:avLst/>
+          </a:prstGeom>
+          <a:noFill/>
+        </p:spPr>
+        <p:txBody>
+          <a:bodyPr wrap="square" rtlCol="0">
+            <a:spAutoFit/>
+          </a:bodyPr>
+          <a:lstStyle/>
+          <a:p>
+            <a:r>
+              <a:rPr lang="es-MX" dirty="0">
+                <a:solidFill>
+                  <a:schemeClr val="accent1"/>
+                </a:solidFill>
+                <a:latin typeface="+mj-lt"/>
+              </a:rPr>
+              <a:t>Contexto</a:t>
+            </a:r>
+            <a:endParaRPr lang="es-CL" dirty="0">
+              <a:solidFill>
+                <a:schemeClr val="accent1"/>
+              </a:solidFill>
+              <a:latin typeface="+mj-lt"/>
+            </a:endParaRPr>
+          </a:p>
+        </p:txBody>
+      </p:sp>
+    </p:spTree>
+    <p:extLst>
+      <p:ext uri="{BB962C8B-B14F-4D97-AF65-F5344CB8AC3E}">
+        <p14:creationId xmlns:p14="http://schemas.microsoft.com/office/powerpoint/2010/main" val="3016230215"/>
+      </p:ext>
+    </p:extLst>
+  </p:cSld>
+  <p:clrMapOvr>
+    <a:masterClrMapping/>
+  </p:clrMapOvr>
+</p:sld>
+</file>
+
+<file path=ppt/slides/slide4.xml><?xml version="1.0" encoding="utf-8"?>
+<p:sld xmlns:a="http://schemas.openxmlformats.org/drawingml/2006/main" xmlns:r="http://schemas.openxmlformats.org/officeDocument/2006/relationships" xmlns:p="http://schemas.openxmlformats.org/presentationml/2006/main">
+  <p:cSld>
+    <p:bg>
+      <p:bgPr>
+        <a:solidFill>
+          <a:schemeClr val="tx2"/>
+        </a:solidFill>
+        <a:effectLst/>
+      </p:bgPr>
+    </p:bg>
+    <p:spTree>
+      <p:nvGrpSpPr>
+        <p:cNvPr id="1" name="">
+          <a:extLst>
+            <a:ext uri="{FF2B5EF4-FFF2-40B4-BE49-F238E27FC236}">
+              <a16:creationId xmlns:a16="http://schemas.microsoft.com/office/drawing/2014/main" id="{74E6E7D1-A8CB-59CE-25E5-1D3FFBA186C0}"/>
+            </a:ext>
+          </a:extLst>
+        </p:cNvPr>
+        <p:cNvGrpSpPr/>
+        <p:nvPr/>
+      </p:nvGrpSpPr>
+      <p:grpSpPr>
+        <a:xfrm>
+          <a:off x="0" y="0"/>
+          <a:ext cx="0" cy="0"/>
+          <a:chOff x="0" y="0"/>
+          <a:chExt cx="0" cy="0"/>
+        </a:xfrm>
+      </p:grpSpPr>
+      <p:sp>
+        <p:nvSpPr>
+          <p:cNvPr id="8" name="CuadroTexto 7">
+            <a:extLst>
+              <a:ext uri="{FF2B5EF4-FFF2-40B4-BE49-F238E27FC236}">
+                <a16:creationId xmlns:a16="http://schemas.microsoft.com/office/drawing/2014/main" id="{1BBB11A7-C6C1-2709-8586-91B19AC30FB9}"/>
+              </a:ext>
+            </a:extLst>
+          </p:cNvPr>
+          <p:cNvSpPr txBox="1"/>
+          <p:nvPr/>
+        </p:nvSpPr>
+        <p:spPr>
+          <a:xfrm>
+            <a:off x="2281727" y="2264635"/>
+            <a:ext cx="4349810" cy="2346540"/>
+          </a:xfrm>
+          <a:prstGeom prst="rect">
+            <a:avLst/>
+          </a:prstGeom>
+          <a:noFill/>
+        </p:spPr>
+        <p:txBody>
+          <a:bodyPr wrap="square" rtlCol="0">
+            <a:spAutoFit/>
+          </a:bodyPr>
+          <a:lstStyle/>
+          <a:p>
+            <a:pPr marL="285750" indent="-285750">
+              <a:lnSpc>
+                <a:spcPct val="150000"/>
+              </a:lnSpc>
+              <a:buFont typeface="Arial" panose="020B0604020202020204" pitchFamily="34" charset="0"/>
+              <a:buChar char="•"/>
+            </a:pPr>
+            <a:r>
+              <a:rPr lang="es-MX" sz="2000" dirty="0" err="1">
+                <a:solidFill>
+                  <a:schemeClr val="bg1"/>
+                </a:solidFill>
+              </a:rPr>
+              <a:t>Saf</a:t>
+            </a:r>
+            <a:endParaRPr lang="es-MX" sz="2000" dirty="0">
+              <a:solidFill>
+                <a:schemeClr val="bg1"/>
+              </a:solidFill>
+            </a:endParaRPr>
+          </a:p>
+          <a:p>
+            <a:pPr marL="285750" indent="-285750">
+              <a:lnSpc>
+                <a:spcPct val="150000"/>
+              </a:lnSpc>
+              <a:buFont typeface="Arial" panose="020B0604020202020204" pitchFamily="34" charset="0"/>
+              <a:buChar char="•"/>
+            </a:pPr>
+            <a:endParaRPr lang="es-CL" sz="2000" dirty="0">
+              <a:solidFill>
+                <a:schemeClr val="bg1"/>
+              </a:solidFill>
+            </a:endParaRPr>
+          </a:p>
+          <a:p>
+            <a:pPr marL="285750" indent="-285750">
+              <a:lnSpc>
+                <a:spcPct val="150000"/>
+              </a:lnSpc>
+              <a:buFont typeface="Arial" panose="020B0604020202020204" pitchFamily="34" charset="0"/>
+              <a:buChar char="•"/>
+            </a:pPr>
+            <a:r>
+              <a:rPr lang="es-CL" sz="2000" dirty="0">
+                <a:solidFill>
+                  <a:schemeClr val="bg1"/>
+                </a:solidFill>
+              </a:rPr>
+              <a:t>S</a:t>
+            </a:r>
+          </a:p>
+          <a:p>
+            <a:pPr marL="285750" indent="-285750">
+              <a:lnSpc>
+                <a:spcPct val="150000"/>
+              </a:lnSpc>
+              <a:buFont typeface="Arial" panose="020B0604020202020204" pitchFamily="34" charset="0"/>
+              <a:buChar char="•"/>
+            </a:pPr>
+            <a:endParaRPr lang="es-CL" sz="2000" dirty="0">
+              <a:solidFill>
+                <a:schemeClr val="bg1"/>
+              </a:solidFill>
+            </a:endParaRPr>
+          </a:p>
+          <a:p>
+            <a:pPr marL="285750" indent="-285750">
+              <a:lnSpc>
+                <a:spcPct val="150000"/>
+              </a:lnSpc>
+              <a:buFont typeface="Arial" panose="020B0604020202020204" pitchFamily="34" charset="0"/>
+              <a:buChar char="•"/>
+            </a:pPr>
+            <a:r>
+              <a:rPr lang="es-CL" sz="2000" dirty="0">
+                <a:solidFill>
+                  <a:schemeClr val="bg1"/>
+                </a:solidFill>
+              </a:rPr>
+              <a:t>s</a:t>
+            </a:r>
+            <a:endParaRPr lang="es-MX" sz="2000" dirty="0">
+              <a:solidFill>
+                <a:schemeClr val="bg1"/>
+              </a:solidFill>
+            </a:endParaRPr>
+          </a:p>
+        </p:txBody>
+      </p:sp>
+      <p:grpSp>
+        <p:nvGrpSpPr>
+          <p:cNvPr id="25" name="Grupo 24">
+            <a:extLst>
+              <a:ext uri="{FF2B5EF4-FFF2-40B4-BE49-F238E27FC236}">
+                <a16:creationId xmlns:a16="http://schemas.microsoft.com/office/drawing/2014/main" id="{1E6FD3C3-D76D-BCA6-68F4-128F41F25A06}"/>
+              </a:ext>
+            </a:extLst>
+          </p:cNvPr>
+          <p:cNvGrpSpPr/>
+          <p:nvPr/>
+        </p:nvGrpSpPr>
+        <p:grpSpPr>
+          <a:xfrm>
+            <a:off x="841727" y="546930"/>
+            <a:ext cx="2880000" cy="540000"/>
+            <a:chOff x="786213" y="521293"/>
+            <a:chExt cx="2880000" cy="540000"/>
+          </a:xfrm>
+        </p:grpSpPr>
+        <p:cxnSp>
+          <p:nvCxnSpPr>
+            <p:cNvPr id="10" name="Conector recto 9">
+              <a:extLst>
+                <a:ext uri="{FF2B5EF4-FFF2-40B4-BE49-F238E27FC236}">
+                  <a16:creationId xmlns:a16="http://schemas.microsoft.com/office/drawing/2014/main" id="{9ADD293C-6241-6C76-6469-43D0282BCE35}"/>
+                </a:ext>
+              </a:extLst>
+            </p:cNvPr>
+            <p:cNvCxnSpPr/>
+            <p:nvPr/>
+          </p:nvCxnSpPr>
+          <p:spPr>
+            <a:xfrm>
+              <a:off x="786213" y="521293"/>
+              <a:ext cx="0" cy="540000"/>
+            </a:xfrm>
+            <a:prstGeom prst="line">
+              <a:avLst/>
+            </a:prstGeom>
+          </p:spPr>
+          <p:style>
+            <a:lnRef idx="3">
+              <a:schemeClr val="accent2"/>
+            </a:lnRef>
+            <a:fillRef idx="0">
+              <a:schemeClr val="accent2"/>
+            </a:fillRef>
+            <a:effectRef idx="2">
+              <a:schemeClr val="accent2"/>
+            </a:effectRef>
+            <a:fontRef idx="minor">
+              <a:schemeClr val="tx1"/>
+            </a:fontRef>
+          </p:style>
+        </p:cxnSp>
+        <p:cxnSp>
+          <p:nvCxnSpPr>
+            <p:cNvPr id="14" name="Conector recto 13">
+              <a:extLst>
+                <a:ext uri="{FF2B5EF4-FFF2-40B4-BE49-F238E27FC236}">
+                  <a16:creationId xmlns:a16="http://schemas.microsoft.com/office/drawing/2014/main" id="{643A3B96-FD48-C215-3BB0-D0401F210303}"/>
+                </a:ext>
+              </a:extLst>
+            </p:cNvPr>
+            <p:cNvCxnSpPr>
+              <a:cxnSpLocks/>
+            </p:cNvCxnSpPr>
+            <p:nvPr/>
+          </p:nvCxnSpPr>
+          <p:spPr>
+            <a:xfrm>
+              <a:off x="786213" y="1061293"/>
+              <a:ext cx="2880000" cy="0"/>
+            </a:xfrm>
+            <a:prstGeom prst="line">
+              <a:avLst/>
+            </a:prstGeom>
+          </p:spPr>
+          <p:style>
+            <a:lnRef idx="3">
+              <a:schemeClr val="accent2"/>
+            </a:lnRef>
+            <a:fillRef idx="0">
+              <a:schemeClr val="accent2"/>
+            </a:fillRef>
+            <a:effectRef idx="2">
+              <a:schemeClr val="accent2"/>
+            </a:effectRef>
+            <a:fontRef idx="minor">
+              <a:schemeClr val="tx1"/>
+            </a:fontRef>
+          </p:style>
+        </p:cxnSp>
+      </p:grpSp>
+      <p:sp>
+        <p:nvSpPr>
+          <p:cNvPr id="3" name="CuadroTexto 2">
+            <a:extLst>
+              <a:ext uri="{FF2B5EF4-FFF2-40B4-BE49-F238E27FC236}">
+                <a16:creationId xmlns:a16="http://schemas.microsoft.com/office/drawing/2014/main" id="{0184CF6D-2473-0C0C-91D4-4826F8C50515}"/>
+              </a:ext>
+            </a:extLst>
+          </p:cNvPr>
+          <p:cNvSpPr txBox="1"/>
+          <p:nvPr/>
+        </p:nvSpPr>
+        <p:spPr>
+          <a:xfrm>
+            <a:off x="1031888" y="555724"/>
+            <a:ext cx="2499678" cy="369332"/>
+          </a:xfrm>
+          <a:prstGeom prst="rect">
+            <a:avLst/>
+          </a:prstGeom>
+          <a:noFill/>
+        </p:spPr>
+        <p:txBody>
+          <a:bodyPr wrap="square" rtlCol="0">
+            <a:spAutoFit/>
+          </a:bodyPr>
+          <a:lstStyle/>
+          <a:p>
+            <a:r>
+              <a:rPr lang="es-MX" dirty="0">
+                <a:solidFill>
+                  <a:schemeClr val="accent1"/>
+                </a:solidFill>
+                <a:latin typeface="+mj-lt"/>
+              </a:rPr>
+              <a:t>Problemática</a:t>
+            </a:r>
+            <a:endParaRPr lang="es-CL" dirty="0">
+              <a:solidFill>
+                <a:schemeClr val="accent1"/>
+              </a:solidFill>
+              <a:latin typeface="+mj-lt"/>
+            </a:endParaRPr>
+          </a:p>
+        </p:txBody>
+      </p:sp>
+    </p:spTree>
+    <p:extLst>
+      <p:ext uri="{BB962C8B-B14F-4D97-AF65-F5344CB8AC3E}">
+        <p14:creationId xmlns:p14="http://schemas.microsoft.com/office/powerpoint/2010/main" val="2158553757"/>
+      </p:ext>
+    </p:extLst>
+  </p:cSld>
+  <p:clrMapOvr>
+    <a:masterClrMapping/>
+  </p:clrMapOvr>
+</p:sld>
+</file>
+
+<file path=ppt/slides/slide5.xml><?xml version="1.0" encoding="utf-8"?>
+<p:sld xmlns:a="http://schemas.openxmlformats.org/drawingml/2006/main" xmlns:r="http://schemas.openxmlformats.org/officeDocument/2006/relationships" xmlns:p="http://schemas.openxmlformats.org/presentationml/2006/main">
+  <p:cSld>
+    <p:bg>
+      <p:bgPr>
+        <a:solidFill>
+          <a:schemeClr val="tx2"/>
+        </a:solidFill>
+        <a:effectLst/>
+      </p:bgPr>
+    </p:bg>
+    <p:spTree>
+      <p:nvGrpSpPr>
+        <p:cNvPr id="1" name="">
+          <a:extLst>
+            <a:ext uri="{FF2B5EF4-FFF2-40B4-BE49-F238E27FC236}">
+              <a16:creationId xmlns:a16="http://schemas.microsoft.com/office/drawing/2014/main" id="{12CD3DAA-EC76-4D2B-7B14-F9F33C6735ED}"/>
+            </a:ext>
+          </a:extLst>
+        </p:cNvPr>
+        <p:cNvGrpSpPr/>
+        <p:nvPr/>
+      </p:nvGrpSpPr>
+      <p:grpSpPr>
+        <a:xfrm>
+          <a:off x="0" y="0"/>
+          <a:ext cx="0" cy="0"/>
+          <a:chOff x="0" y="0"/>
+          <a:chExt cx="0" cy="0"/>
+        </a:xfrm>
+      </p:grpSpPr>
+      <p:sp>
+        <p:nvSpPr>
+          <p:cNvPr id="8" name="CuadroTexto 7">
+            <a:extLst>
+              <a:ext uri="{FF2B5EF4-FFF2-40B4-BE49-F238E27FC236}">
+                <a16:creationId xmlns:a16="http://schemas.microsoft.com/office/drawing/2014/main" id="{CB9D833E-7075-8BC0-8C3B-2DF7509CA7BB}"/>
+              </a:ext>
+            </a:extLst>
+          </p:cNvPr>
+          <p:cNvSpPr txBox="1"/>
+          <p:nvPr/>
+        </p:nvSpPr>
+        <p:spPr>
+          <a:xfrm>
+            <a:off x="2281727" y="2264635"/>
+            <a:ext cx="4349810" cy="2346540"/>
+          </a:xfrm>
+          <a:prstGeom prst="rect">
+            <a:avLst/>
+          </a:prstGeom>
+          <a:noFill/>
+        </p:spPr>
+        <p:txBody>
+          <a:bodyPr wrap="square" rtlCol="0">
+            <a:spAutoFit/>
+          </a:bodyPr>
+          <a:lstStyle/>
+          <a:p>
+            <a:pPr marL="285750" indent="-285750">
+              <a:lnSpc>
+                <a:spcPct val="150000"/>
+              </a:lnSpc>
+              <a:buFont typeface="Arial" panose="020B0604020202020204" pitchFamily="34" charset="0"/>
+              <a:buChar char="•"/>
+            </a:pPr>
+            <a:r>
+              <a:rPr lang="es-MX" sz="2000" dirty="0" err="1">
+                <a:solidFill>
+                  <a:schemeClr val="bg1"/>
+                </a:solidFill>
+              </a:rPr>
+              <a:t>Saf</a:t>
+            </a:r>
+            <a:endParaRPr lang="es-MX" sz="2000" dirty="0">
+              <a:solidFill>
+                <a:schemeClr val="bg1"/>
+              </a:solidFill>
+            </a:endParaRPr>
+          </a:p>
+          <a:p>
+            <a:pPr marL="285750" indent="-285750">
+              <a:lnSpc>
+                <a:spcPct val="150000"/>
+              </a:lnSpc>
+              <a:buFont typeface="Arial" panose="020B0604020202020204" pitchFamily="34" charset="0"/>
+              <a:buChar char="•"/>
+            </a:pPr>
+            <a:endParaRPr lang="es-CL" sz="2000" dirty="0">
+              <a:solidFill>
+                <a:schemeClr val="bg1"/>
+              </a:solidFill>
+            </a:endParaRPr>
+          </a:p>
+          <a:p>
+            <a:pPr marL="285750" indent="-285750">
+              <a:lnSpc>
+                <a:spcPct val="150000"/>
+              </a:lnSpc>
+              <a:buFont typeface="Arial" panose="020B0604020202020204" pitchFamily="34" charset="0"/>
+              <a:buChar char="•"/>
+            </a:pPr>
+            <a:r>
+              <a:rPr lang="es-CL" sz="2000" dirty="0">
+                <a:solidFill>
+                  <a:schemeClr val="bg1"/>
+                </a:solidFill>
+              </a:rPr>
+              <a:t>S</a:t>
+            </a:r>
+          </a:p>
+          <a:p>
+            <a:pPr marL="285750" indent="-285750">
+              <a:lnSpc>
+                <a:spcPct val="150000"/>
+              </a:lnSpc>
+              <a:buFont typeface="Arial" panose="020B0604020202020204" pitchFamily="34" charset="0"/>
+              <a:buChar char="•"/>
+            </a:pPr>
+            <a:endParaRPr lang="es-CL" sz="2000" dirty="0">
+              <a:solidFill>
+                <a:schemeClr val="bg1"/>
+              </a:solidFill>
+            </a:endParaRPr>
+          </a:p>
+          <a:p>
+            <a:pPr marL="285750" indent="-285750">
+              <a:lnSpc>
+                <a:spcPct val="150000"/>
+              </a:lnSpc>
+              <a:buFont typeface="Arial" panose="020B0604020202020204" pitchFamily="34" charset="0"/>
+              <a:buChar char="•"/>
+            </a:pPr>
+            <a:r>
+              <a:rPr lang="es-CL" sz="2000" dirty="0">
+                <a:solidFill>
+                  <a:schemeClr val="bg1"/>
+                </a:solidFill>
+              </a:rPr>
+              <a:t>s</a:t>
+            </a:r>
+            <a:endParaRPr lang="es-MX" sz="2000" dirty="0">
+              <a:solidFill>
+                <a:schemeClr val="bg1"/>
+              </a:solidFill>
+            </a:endParaRPr>
+          </a:p>
+        </p:txBody>
+      </p:sp>
+      <p:grpSp>
+        <p:nvGrpSpPr>
+          <p:cNvPr id="25" name="Grupo 24">
+            <a:extLst>
+              <a:ext uri="{FF2B5EF4-FFF2-40B4-BE49-F238E27FC236}">
+                <a16:creationId xmlns:a16="http://schemas.microsoft.com/office/drawing/2014/main" id="{CC8ED33D-819C-93A4-DA16-43A4C22921CC}"/>
+              </a:ext>
+            </a:extLst>
+          </p:cNvPr>
+          <p:cNvGrpSpPr/>
+          <p:nvPr/>
+        </p:nvGrpSpPr>
+        <p:grpSpPr>
+          <a:xfrm>
+            <a:off x="841727" y="546930"/>
+            <a:ext cx="2880000" cy="540000"/>
+            <a:chOff x="786213" y="521293"/>
+            <a:chExt cx="2880000" cy="540000"/>
+          </a:xfrm>
+        </p:grpSpPr>
+        <p:cxnSp>
+          <p:nvCxnSpPr>
+            <p:cNvPr id="10" name="Conector recto 9">
+              <a:extLst>
+                <a:ext uri="{FF2B5EF4-FFF2-40B4-BE49-F238E27FC236}">
+                  <a16:creationId xmlns:a16="http://schemas.microsoft.com/office/drawing/2014/main" id="{7D52BC26-EB38-21B4-CCEB-9E3D3CB9C4D1}"/>
+                </a:ext>
+              </a:extLst>
+            </p:cNvPr>
+            <p:cNvCxnSpPr/>
+            <p:nvPr/>
+          </p:nvCxnSpPr>
+          <p:spPr>
+            <a:xfrm>
+              <a:off x="786213" y="521293"/>
+              <a:ext cx="0" cy="540000"/>
+            </a:xfrm>
+            <a:prstGeom prst="line">
+              <a:avLst/>
+            </a:prstGeom>
+          </p:spPr>
+          <p:style>
+            <a:lnRef idx="3">
+              <a:schemeClr val="accent2"/>
+            </a:lnRef>
+            <a:fillRef idx="0">
+              <a:schemeClr val="accent2"/>
+            </a:fillRef>
+            <a:effectRef idx="2">
+              <a:schemeClr val="accent2"/>
+            </a:effectRef>
+            <a:fontRef idx="minor">
+              <a:schemeClr val="tx1"/>
+            </a:fontRef>
+          </p:style>
+        </p:cxnSp>
+        <p:cxnSp>
+          <p:nvCxnSpPr>
+            <p:cNvPr id="14" name="Conector recto 13">
+              <a:extLst>
+                <a:ext uri="{FF2B5EF4-FFF2-40B4-BE49-F238E27FC236}">
+                  <a16:creationId xmlns:a16="http://schemas.microsoft.com/office/drawing/2014/main" id="{9C98B482-3BB1-743C-8030-D11588CAA0AF}"/>
+                </a:ext>
+              </a:extLst>
+            </p:cNvPr>
+            <p:cNvCxnSpPr>
+              <a:cxnSpLocks/>
+            </p:cNvCxnSpPr>
+            <p:nvPr/>
+          </p:nvCxnSpPr>
+          <p:spPr>
+            <a:xfrm>
+              <a:off x="786213" y="1061293"/>
+              <a:ext cx="2880000" cy="0"/>
+            </a:xfrm>
+            <a:prstGeom prst="line">
+              <a:avLst/>
+            </a:prstGeom>
+          </p:spPr>
+          <p:style>
+            <a:lnRef idx="3">
+              <a:schemeClr val="accent2"/>
+            </a:lnRef>
+            <a:fillRef idx="0">
+              <a:schemeClr val="accent2"/>
+            </a:fillRef>
+            <a:effectRef idx="2">
+              <a:schemeClr val="accent2"/>
+            </a:effectRef>
+            <a:fontRef idx="minor">
+              <a:schemeClr val="tx1"/>
+            </a:fontRef>
+          </p:style>
+        </p:cxnSp>
+      </p:grpSp>
+      <p:sp>
+        <p:nvSpPr>
+          <p:cNvPr id="3" name="CuadroTexto 2">
+            <a:extLst>
+              <a:ext uri="{FF2B5EF4-FFF2-40B4-BE49-F238E27FC236}">
+                <a16:creationId xmlns:a16="http://schemas.microsoft.com/office/drawing/2014/main" id="{D6D4D9EB-CC89-7E64-F89B-39FF7E7490AF}"/>
+              </a:ext>
+            </a:extLst>
+          </p:cNvPr>
+          <p:cNvSpPr txBox="1"/>
+          <p:nvPr/>
+        </p:nvSpPr>
+        <p:spPr>
+          <a:xfrm>
+            <a:off x="1031888" y="502155"/>
+            <a:ext cx="2499678" cy="584775"/>
+          </a:xfrm>
+          <a:prstGeom prst="rect">
+            <a:avLst/>
+          </a:prstGeom>
+          <a:noFill/>
+        </p:spPr>
+        <p:txBody>
+          <a:bodyPr wrap="square" rtlCol="0">
+            <a:spAutoFit/>
+          </a:bodyPr>
+          <a:lstStyle/>
+          <a:p>
+            <a:r>
+              <a:rPr lang="es-MX" sz="1600" dirty="0">
+                <a:solidFill>
+                  <a:schemeClr val="accent1"/>
+                </a:solidFill>
+                <a:latin typeface="+mj-lt"/>
+              </a:rPr>
+              <a:t>Propuesta de Solución</a:t>
+            </a:r>
+            <a:endParaRPr lang="es-CL" sz="1600" dirty="0">
+              <a:solidFill>
+                <a:schemeClr val="accent1"/>
+              </a:solidFill>
+              <a:latin typeface="+mj-lt"/>
+            </a:endParaRPr>
+          </a:p>
+        </p:txBody>
+      </p:sp>
+    </p:spTree>
+    <p:extLst>
+      <p:ext uri="{BB962C8B-B14F-4D97-AF65-F5344CB8AC3E}">
+        <p14:creationId xmlns:p14="http://schemas.microsoft.com/office/powerpoint/2010/main" val="1263538641"/>
+      </p:ext>
+    </p:extLst>
+  </p:cSld>
+  <p:clrMapOvr>
+    <a:masterClrMapping/>
+  </p:clrMapOvr>
+</p:sld>
+</file>
+
+<file path=ppt/slides/slide6.xml><?xml version="1.0" encoding="utf-8"?>
+<p:sld xmlns:a="http://schemas.openxmlformats.org/drawingml/2006/main" xmlns:r="http://schemas.openxmlformats.org/officeDocument/2006/relationships" xmlns:p="http://schemas.openxmlformats.org/presentationml/2006/main">
+  <p:cSld>
+    <p:bg>
+      <p:bgPr>
+        <a:solidFill>
+          <a:schemeClr val="tx2"/>
+        </a:solidFill>
+        <a:effectLst/>
+      </p:bgPr>
+    </p:bg>
+    <p:spTree>
+      <p:nvGrpSpPr>
+        <p:cNvPr id="1" name="">
+          <a:extLst>
+            <a:ext uri="{FF2B5EF4-FFF2-40B4-BE49-F238E27FC236}">
+              <a16:creationId xmlns:a16="http://schemas.microsoft.com/office/drawing/2014/main" id="{256D6CAD-235E-3CA4-EC68-0B31B775B3BA}"/>
+            </a:ext>
+          </a:extLst>
+        </p:cNvPr>
+        <p:cNvGrpSpPr/>
+        <p:nvPr/>
+      </p:nvGrpSpPr>
+      <p:grpSpPr>
+        <a:xfrm>
+          <a:off x="0" y="0"/>
+          <a:ext cx="0" cy="0"/>
+          <a:chOff x="0" y="0"/>
+          <a:chExt cx="0" cy="0"/>
+        </a:xfrm>
+      </p:grpSpPr>
+      <p:sp>
+        <p:nvSpPr>
+          <p:cNvPr id="8" name="CuadroTexto 7">
+            <a:extLst>
+              <a:ext uri="{FF2B5EF4-FFF2-40B4-BE49-F238E27FC236}">
+                <a16:creationId xmlns:a16="http://schemas.microsoft.com/office/drawing/2014/main" id="{B1C796F1-C09E-5B89-AEDB-EB3778C6A5CA}"/>
+              </a:ext>
+            </a:extLst>
+          </p:cNvPr>
+          <p:cNvSpPr txBox="1"/>
+          <p:nvPr/>
+        </p:nvSpPr>
+        <p:spPr>
+          <a:xfrm>
+            <a:off x="2281727" y="2264635"/>
+            <a:ext cx="4349810" cy="2346540"/>
+          </a:xfrm>
+          <a:prstGeom prst="rect">
+            <a:avLst/>
+          </a:prstGeom>
+          <a:noFill/>
+        </p:spPr>
+        <p:txBody>
+          <a:bodyPr wrap="square" rtlCol="0">
+            <a:spAutoFit/>
+          </a:bodyPr>
+          <a:lstStyle/>
+          <a:p>
+            <a:pPr marL="285750" indent="-285750">
+              <a:lnSpc>
+                <a:spcPct val="150000"/>
+              </a:lnSpc>
+              <a:buFont typeface="Arial" panose="020B0604020202020204" pitchFamily="34" charset="0"/>
+              <a:buChar char="•"/>
+            </a:pPr>
+            <a:r>
+              <a:rPr lang="es-MX" sz="2000" dirty="0" err="1">
+                <a:solidFill>
+                  <a:schemeClr val="bg1"/>
+                </a:solidFill>
+              </a:rPr>
+              <a:t>Saf</a:t>
+            </a:r>
+            <a:endParaRPr lang="es-MX" sz="2000" dirty="0">
+              <a:solidFill>
+                <a:schemeClr val="bg1"/>
+              </a:solidFill>
+            </a:endParaRPr>
+          </a:p>
+          <a:p>
+            <a:pPr marL="285750" indent="-285750">
+              <a:lnSpc>
+                <a:spcPct val="150000"/>
+              </a:lnSpc>
+              <a:buFont typeface="Arial" panose="020B0604020202020204" pitchFamily="34" charset="0"/>
+              <a:buChar char="•"/>
+            </a:pPr>
+            <a:endParaRPr lang="es-CL" sz="2000" dirty="0">
+              <a:solidFill>
+                <a:schemeClr val="bg1"/>
+              </a:solidFill>
+            </a:endParaRPr>
+          </a:p>
+          <a:p>
+            <a:pPr marL="285750" indent="-285750">
+              <a:lnSpc>
+                <a:spcPct val="150000"/>
+              </a:lnSpc>
+              <a:buFont typeface="Arial" panose="020B0604020202020204" pitchFamily="34" charset="0"/>
+              <a:buChar char="•"/>
+            </a:pPr>
+            <a:r>
+              <a:rPr lang="es-CL" sz="2000" dirty="0">
+                <a:solidFill>
+                  <a:schemeClr val="bg1"/>
+                </a:solidFill>
+              </a:rPr>
+              <a:t>S</a:t>
+            </a:r>
+          </a:p>
+          <a:p>
+            <a:pPr marL="285750" indent="-285750">
+              <a:lnSpc>
+                <a:spcPct val="150000"/>
+              </a:lnSpc>
+              <a:buFont typeface="Arial" panose="020B0604020202020204" pitchFamily="34" charset="0"/>
+              <a:buChar char="•"/>
+            </a:pPr>
+            <a:endParaRPr lang="es-CL" sz="2000" dirty="0">
+              <a:solidFill>
+                <a:schemeClr val="bg1"/>
+              </a:solidFill>
+            </a:endParaRPr>
+          </a:p>
+          <a:p>
+            <a:pPr marL="285750" indent="-285750">
+              <a:lnSpc>
+                <a:spcPct val="150000"/>
+              </a:lnSpc>
+              <a:buFont typeface="Arial" panose="020B0604020202020204" pitchFamily="34" charset="0"/>
+              <a:buChar char="•"/>
+            </a:pPr>
+            <a:r>
+              <a:rPr lang="es-CL" sz="2000" dirty="0">
+                <a:solidFill>
+                  <a:schemeClr val="bg1"/>
+                </a:solidFill>
+              </a:rPr>
+              <a:t>s</a:t>
+            </a:r>
+            <a:endParaRPr lang="es-MX" sz="2000" dirty="0">
+              <a:solidFill>
+                <a:schemeClr val="bg1"/>
+              </a:solidFill>
+            </a:endParaRPr>
+          </a:p>
+        </p:txBody>
+      </p:sp>
+      <p:grpSp>
+        <p:nvGrpSpPr>
+          <p:cNvPr id="25" name="Grupo 24">
+            <a:extLst>
+              <a:ext uri="{FF2B5EF4-FFF2-40B4-BE49-F238E27FC236}">
+                <a16:creationId xmlns:a16="http://schemas.microsoft.com/office/drawing/2014/main" id="{5C1E000F-0678-BC9F-4398-D81B154A439A}"/>
+              </a:ext>
+            </a:extLst>
+          </p:cNvPr>
+          <p:cNvGrpSpPr/>
+          <p:nvPr/>
+        </p:nvGrpSpPr>
+        <p:grpSpPr>
+          <a:xfrm>
+            <a:off x="841727" y="546930"/>
+            <a:ext cx="2880000" cy="540000"/>
+            <a:chOff x="786213" y="521293"/>
+            <a:chExt cx="2880000" cy="540000"/>
+          </a:xfrm>
+        </p:grpSpPr>
+        <p:cxnSp>
+          <p:nvCxnSpPr>
+            <p:cNvPr id="10" name="Conector recto 9">
+              <a:extLst>
+                <a:ext uri="{FF2B5EF4-FFF2-40B4-BE49-F238E27FC236}">
+                  <a16:creationId xmlns:a16="http://schemas.microsoft.com/office/drawing/2014/main" id="{D9573E72-B276-4BA2-9D40-8675310FC4D5}"/>
+                </a:ext>
+              </a:extLst>
+            </p:cNvPr>
+            <p:cNvCxnSpPr/>
+            <p:nvPr/>
+          </p:nvCxnSpPr>
+          <p:spPr>
+            <a:xfrm>
+              <a:off x="786213" y="521293"/>
+              <a:ext cx="0" cy="540000"/>
+            </a:xfrm>
+            <a:prstGeom prst="line">
+              <a:avLst/>
+            </a:prstGeom>
+          </p:spPr>
+          <p:style>
+            <a:lnRef idx="3">
+              <a:schemeClr val="accent2"/>
+            </a:lnRef>
+            <a:fillRef idx="0">
+              <a:schemeClr val="accent2"/>
+            </a:fillRef>
+            <a:effectRef idx="2">
+              <a:schemeClr val="accent2"/>
+            </a:effectRef>
+            <a:fontRef idx="minor">
+              <a:schemeClr val="tx1"/>
+            </a:fontRef>
+          </p:style>
+        </p:cxnSp>
+        <p:cxnSp>
+          <p:nvCxnSpPr>
+            <p:cNvPr id="14" name="Conector recto 13">
+              <a:extLst>
+                <a:ext uri="{FF2B5EF4-FFF2-40B4-BE49-F238E27FC236}">
+                  <a16:creationId xmlns:a16="http://schemas.microsoft.com/office/drawing/2014/main" id="{349EC342-CD37-A9A2-E12C-585B612FF5B3}"/>
+                </a:ext>
+              </a:extLst>
+            </p:cNvPr>
+            <p:cNvCxnSpPr>
+              <a:cxnSpLocks/>
+            </p:cNvCxnSpPr>
+            <p:nvPr/>
+          </p:nvCxnSpPr>
+          <p:spPr>
+            <a:xfrm>
+              <a:off x="786213" y="1061293"/>
+              <a:ext cx="2880000" cy="0"/>
+            </a:xfrm>
+            <a:prstGeom prst="line">
+              <a:avLst/>
+            </a:prstGeom>
+          </p:spPr>
+          <p:style>
+            <a:lnRef idx="3">
+              <a:schemeClr val="accent2"/>
+            </a:lnRef>
+            <a:fillRef idx="0">
+              <a:schemeClr val="accent2"/>
+            </a:fillRef>
+            <a:effectRef idx="2">
+              <a:schemeClr val="accent2"/>
+            </a:effectRef>
+            <a:fontRef idx="minor">
+              <a:schemeClr val="tx1"/>
+            </a:fontRef>
+          </p:style>
+        </p:cxnSp>
+      </p:grpSp>
+      <p:sp>
+        <p:nvSpPr>
+          <p:cNvPr id="3" name="CuadroTexto 2">
+            <a:extLst>
+              <a:ext uri="{FF2B5EF4-FFF2-40B4-BE49-F238E27FC236}">
+                <a16:creationId xmlns:a16="http://schemas.microsoft.com/office/drawing/2014/main" id="{5F98089D-1DC2-36E4-88CE-13C5D75EAD87}"/>
+              </a:ext>
+            </a:extLst>
+          </p:cNvPr>
+          <p:cNvSpPr txBox="1"/>
+          <p:nvPr/>
+        </p:nvSpPr>
+        <p:spPr>
+          <a:xfrm>
+            <a:off x="1031888" y="555724"/>
+            <a:ext cx="2499678" cy="369332"/>
+          </a:xfrm>
+          <a:prstGeom prst="rect">
+            <a:avLst/>
+          </a:prstGeom>
+          <a:noFill/>
+        </p:spPr>
+        <p:txBody>
+          <a:bodyPr wrap="square" rtlCol="0">
+            <a:spAutoFit/>
+          </a:bodyPr>
+          <a:lstStyle/>
+          <a:p>
+            <a:r>
+              <a:rPr lang="es-MX" dirty="0">
+                <a:solidFill>
+                  <a:schemeClr val="accent1"/>
+                </a:solidFill>
+                <a:latin typeface="+mj-lt"/>
+              </a:rPr>
+              <a:t>Metodología</a:t>
+            </a:r>
+            <a:endParaRPr lang="es-CL" dirty="0">
+              <a:solidFill>
+                <a:schemeClr val="accent1"/>
+              </a:solidFill>
+              <a:latin typeface="+mj-lt"/>
+            </a:endParaRPr>
+          </a:p>
+        </p:txBody>
+      </p:sp>
+    </p:spTree>
+    <p:extLst>
+      <p:ext uri="{BB962C8B-B14F-4D97-AF65-F5344CB8AC3E}">
+        <p14:creationId xmlns:p14="http://schemas.microsoft.com/office/powerpoint/2010/main" val="2420977306"/>
+      </p:ext>
+    </p:extLst>
+  </p:cSld>
+  <p:clrMapOvr>
+    <a:masterClrMapping/>
+  </p:clrMapOvr>
+</p:sld>
+</file>
+
+<file path=ppt/slides/slide7.xml><?xml version="1.0" encoding="utf-8"?>
+<p:sld xmlns:a="http://schemas.openxmlformats.org/drawingml/2006/main" xmlns:r="http://schemas.openxmlformats.org/officeDocument/2006/relationships" xmlns:p="http://schemas.openxmlformats.org/presentationml/2006/main">
+  <p:cSld>
+    <p:bg>
+      <p:bgPr>
+        <a:solidFill>
+          <a:schemeClr val="tx2"/>
+        </a:solidFill>
+        <a:effectLst/>
+      </p:bgPr>
+    </p:bg>
+    <p:spTree>
+      <p:nvGrpSpPr>
+        <p:cNvPr id="1" name="">
+          <a:extLst>
+            <a:ext uri="{FF2B5EF4-FFF2-40B4-BE49-F238E27FC236}">
+              <a16:creationId xmlns:a16="http://schemas.microsoft.com/office/drawing/2014/main" id="{A02160D9-8295-011B-597F-3A87A890CCF8}"/>
+            </a:ext>
+          </a:extLst>
+        </p:cNvPr>
+        <p:cNvGrpSpPr/>
+        <p:nvPr/>
+      </p:nvGrpSpPr>
+      <p:grpSpPr>
+        <a:xfrm>
+          <a:off x="0" y="0"/>
+          <a:ext cx="0" cy="0"/>
+          <a:chOff x="0" y="0"/>
+          <a:chExt cx="0" cy="0"/>
+        </a:xfrm>
+      </p:grpSpPr>
+      <p:sp>
+        <p:nvSpPr>
+          <p:cNvPr id="8" name="CuadroTexto 7">
+            <a:extLst>
+              <a:ext uri="{FF2B5EF4-FFF2-40B4-BE49-F238E27FC236}">
+                <a16:creationId xmlns:a16="http://schemas.microsoft.com/office/drawing/2014/main" id="{F91A507E-95BB-1285-36AD-49FA92A72A3E}"/>
+              </a:ext>
+            </a:extLst>
+          </p:cNvPr>
+          <p:cNvSpPr txBox="1"/>
+          <p:nvPr/>
+        </p:nvSpPr>
+        <p:spPr>
+          <a:xfrm>
+            <a:off x="2281727" y="2264635"/>
+            <a:ext cx="4349810" cy="2346540"/>
+          </a:xfrm>
+          <a:prstGeom prst="rect">
+            <a:avLst/>
+          </a:prstGeom>
+          <a:noFill/>
+        </p:spPr>
+        <p:txBody>
+          <a:bodyPr wrap="square" rtlCol="0">
+            <a:spAutoFit/>
+          </a:bodyPr>
+          <a:lstStyle/>
+          <a:p>
+            <a:pPr marL="285750" indent="-285750">
+              <a:lnSpc>
+                <a:spcPct val="150000"/>
+              </a:lnSpc>
+              <a:buFont typeface="Arial" panose="020B0604020202020204" pitchFamily="34" charset="0"/>
+              <a:buChar char="•"/>
+            </a:pPr>
+            <a:r>
+              <a:rPr lang="es-MX" sz="2000" dirty="0" err="1">
+                <a:solidFill>
+                  <a:schemeClr val="bg1"/>
+                </a:solidFill>
+              </a:rPr>
+              <a:t>Saf</a:t>
+            </a:r>
+            <a:endParaRPr lang="es-MX" sz="2000" dirty="0">
+              <a:solidFill>
+                <a:schemeClr val="bg1"/>
+              </a:solidFill>
+            </a:endParaRPr>
+          </a:p>
+          <a:p>
+            <a:pPr marL="285750" indent="-285750">
+              <a:lnSpc>
+                <a:spcPct val="150000"/>
+              </a:lnSpc>
+              <a:buFont typeface="Arial" panose="020B0604020202020204" pitchFamily="34" charset="0"/>
+              <a:buChar char="•"/>
+            </a:pPr>
+            <a:endParaRPr lang="es-CL" sz="2000" dirty="0">
+              <a:solidFill>
+                <a:schemeClr val="bg1"/>
+              </a:solidFill>
+            </a:endParaRPr>
+          </a:p>
+          <a:p>
+            <a:pPr marL="285750" indent="-285750">
+              <a:lnSpc>
+                <a:spcPct val="150000"/>
+              </a:lnSpc>
+              <a:buFont typeface="Arial" panose="020B0604020202020204" pitchFamily="34" charset="0"/>
+              <a:buChar char="•"/>
+            </a:pPr>
+            <a:r>
+              <a:rPr lang="es-CL" sz="2000" dirty="0">
+                <a:solidFill>
+                  <a:schemeClr val="bg1"/>
+                </a:solidFill>
+              </a:rPr>
+              <a:t>S</a:t>
+            </a:r>
+          </a:p>
+          <a:p>
+            <a:pPr marL="285750" indent="-285750">
+              <a:lnSpc>
+                <a:spcPct val="150000"/>
+              </a:lnSpc>
+              <a:buFont typeface="Arial" panose="020B0604020202020204" pitchFamily="34" charset="0"/>
+              <a:buChar char="•"/>
+            </a:pPr>
+            <a:endParaRPr lang="es-CL" sz="2000" dirty="0">
+              <a:solidFill>
+                <a:schemeClr val="bg1"/>
+              </a:solidFill>
+            </a:endParaRPr>
+          </a:p>
+          <a:p>
+            <a:pPr marL="285750" indent="-285750">
+              <a:lnSpc>
+                <a:spcPct val="150000"/>
+              </a:lnSpc>
+              <a:buFont typeface="Arial" panose="020B0604020202020204" pitchFamily="34" charset="0"/>
+              <a:buChar char="•"/>
+            </a:pPr>
+            <a:r>
+              <a:rPr lang="es-CL" sz="2000" dirty="0">
+                <a:solidFill>
+                  <a:schemeClr val="bg1"/>
+                </a:solidFill>
+              </a:rPr>
+              <a:t>s</a:t>
+            </a:r>
+            <a:endParaRPr lang="es-MX" sz="2000" dirty="0">
+              <a:solidFill>
+                <a:schemeClr val="bg1"/>
+              </a:solidFill>
+            </a:endParaRPr>
+          </a:p>
+        </p:txBody>
+      </p:sp>
+      <p:grpSp>
+        <p:nvGrpSpPr>
+          <p:cNvPr id="25" name="Grupo 24">
+            <a:extLst>
+              <a:ext uri="{FF2B5EF4-FFF2-40B4-BE49-F238E27FC236}">
+                <a16:creationId xmlns:a16="http://schemas.microsoft.com/office/drawing/2014/main" id="{4DB2700E-45E4-6FDE-1D9D-5AC6ED6413E6}"/>
+              </a:ext>
+            </a:extLst>
+          </p:cNvPr>
+          <p:cNvGrpSpPr/>
+          <p:nvPr/>
+        </p:nvGrpSpPr>
+        <p:grpSpPr>
+          <a:xfrm>
+            <a:off x="841727" y="546930"/>
+            <a:ext cx="2880000" cy="540000"/>
+            <a:chOff x="786213" y="521293"/>
+            <a:chExt cx="2880000" cy="540000"/>
+          </a:xfrm>
+        </p:grpSpPr>
+        <p:cxnSp>
+          <p:nvCxnSpPr>
+            <p:cNvPr id="10" name="Conector recto 9">
+              <a:extLst>
+                <a:ext uri="{FF2B5EF4-FFF2-40B4-BE49-F238E27FC236}">
+                  <a16:creationId xmlns:a16="http://schemas.microsoft.com/office/drawing/2014/main" id="{98F212AB-BE6D-2040-D0AF-EF970EAECC80}"/>
+                </a:ext>
+              </a:extLst>
+            </p:cNvPr>
+            <p:cNvCxnSpPr/>
+            <p:nvPr/>
+          </p:nvCxnSpPr>
+          <p:spPr>
+            <a:xfrm>
+              <a:off x="786213" y="521293"/>
+              <a:ext cx="0" cy="540000"/>
+            </a:xfrm>
+            <a:prstGeom prst="line">
+              <a:avLst/>
+            </a:prstGeom>
+          </p:spPr>
+          <p:style>
+            <a:lnRef idx="3">
+              <a:schemeClr val="accent2"/>
+            </a:lnRef>
+            <a:fillRef idx="0">
+              <a:schemeClr val="accent2"/>
+            </a:fillRef>
+            <a:effectRef idx="2">
+              <a:schemeClr val="accent2"/>
+            </a:effectRef>
+            <a:fontRef idx="minor">
+              <a:schemeClr val="tx1"/>
+            </a:fontRef>
+          </p:style>
+        </p:cxnSp>
+        <p:cxnSp>
+          <p:nvCxnSpPr>
+            <p:cNvPr id="14" name="Conector recto 13">
+              <a:extLst>
+                <a:ext uri="{FF2B5EF4-FFF2-40B4-BE49-F238E27FC236}">
+                  <a16:creationId xmlns:a16="http://schemas.microsoft.com/office/drawing/2014/main" id="{C09DBE1A-D8C5-F3C3-62C9-C6BEB1634FEB}"/>
+                </a:ext>
+              </a:extLst>
+            </p:cNvPr>
+            <p:cNvCxnSpPr>
+              <a:cxnSpLocks/>
+            </p:cNvCxnSpPr>
+            <p:nvPr/>
+          </p:nvCxnSpPr>
+          <p:spPr>
+            <a:xfrm>
+              <a:off x="786213" y="1061293"/>
+              <a:ext cx="2880000" cy="0"/>
+            </a:xfrm>
+            <a:prstGeom prst="line">
+              <a:avLst/>
+            </a:prstGeom>
+          </p:spPr>
+          <p:style>
+            <a:lnRef idx="3">
+              <a:schemeClr val="accent2"/>
+            </a:lnRef>
+            <a:fillRef idx="0">
+              <a:schemeClr val="accent2"/>
+            </a:fillRef>
+            <a:effectRef idx="2">
+              <a:schemeClr val="accent2"/>
+            </a:effectRef>
+            <a:fontRef idx="minor">
+              <a:schemeClr val="tx1"/>
+            </a:fontRef>
+          </p:style>
+        </p:cxnSp>
+      </p:grpSp>
+      <p:sp>
+        <p:nvSpPr>
+          <p:cNvPr id="3" name="CuadroTexto 2">
+            <a:extLst>
+              <a:ext uri="{FF2B5EF4-FFF2-40B4-BE49-F238E27FC236}">
+                <a16:creationId xmlns:a16="http://schemas.microsoft.com/office/drawing/2014/main" id="{9F5FCEBF-155E-D8F4-D197-74B481C86AD5}"/>
+              </a:ext>
+            </a:extLst>
+          </p:cNvPr>
+          <p:cNvSpPr txBox="1"/>
+          <p:nvPr/>
+        </p:nvSpPr>
+        <p:spPr>
+          <a:xfrm>
+            <a:off x="1031888" y="555724"/>
+            <a:ext cx="2499678" cy="369332"/>
+          </a:xfrm>
+          <a:prstGeom prst="rect">
+            <a:avLst/>
+          </a:prstGeom>
+          <a:noFill/>
+        </p:spPr>
+        <p:txBody>
+          <a:bodyPr wrap="square" rtlCol="0">
+            <a:spAutoFit/>
+          </a:bodyPr>
+          <a:lstStyle/>
+          <a:p>
+            <a:r>
+              <a:rPr lang="es-MX" dirty="0">
+                <a:solidFill>
+                  <a:schemeClr val="accent1"/>
+                </a:solidFill>
+                <a:latin typeface="+mj-lt"/>
+              </a:rPr>
+              <a:t>Competencias</a:t>
+            </a:r>
+            <a:endParaRPr lang="es-CL" dirty="0">
+              <a:solidFill>
+                <a:schemeClr val="accent1"/>
+              </a:solidFill>
+              <a:latin typeface="+mj-lt"/>
+            </a:endParaRPr>
+          </a:p>
+        </p:txBody>
+      </p:sp>
+    </p:spTree>
+    <p:extLst>
+      <p:ext uri="{BB962C8B-B14F-4D97-AF65-F5344CB8AC3E}">
+        <p14:creationId xmlns:p14="http://schemas.microsoft.com/office/powerpoint/2010/main" val="3460436195"/>
+      </p:ext>
+    </p:extLst>
+  </p:cSld>
+  <p:clrMapOvr>
+    <a:masterClrMapping/>
+  </p:clrMapOvr>
+</p:sld>
+</file>
+
+<file path=ppt/slides/slide8.xml><?xml version="1.0" encoding="utf-8"?>
+<p:sld xmlns:a="http://schemas.openxmlformats.org/drawingml/2006/main" xmlns:r="http://schemas.openxmlformats.org/officeDocument/2006/relationships" xmlns:p="http://schemas.openxmlformats.org/presentationml/2006/main">
+  <p:cSld>
+    <p:bg>
+      <p:bgPr>
+        <a:solidFill>
+          <a:schemeClr val="tx2"/>
+        </a:solidFill>
+        <a:effectLst/>
+      </p:bgPr>
+    </p:bg>
+    <p:spTree>
+      <p:nvGrpSpPr>
+        <p:cNvPr id="1" name="">
+          <a:extLst>
+            <a:ext uri="{FF2B5EF4-FFF2-40B4-BE49-F238E27FC236}">
+              <a16:creationId xmlns:a16="http://schemas.microsoft.com/office/drawing/2014/main" id="{448CFD79-8C0A-30E0-792B-9C272D21AF3A}"/>
+            </a:ext>
+          </a:extLst>
+        </p:cNvPr>
+        <p:cNvGrpSpPr/>
+        <p:nvPr/>
+      </p:nvGrpSpPr>
+      <p:grpSpPr>
+        <a:xfrm>
+          <a:off x="0" y="0"/>
+          <a:ext cx="0" cy="0"/>
+          <a:chOff x="0" y="0"/>
+          <a:chExt cx="0" cy="0"/>
+        </a:xfrm>
+      </p:grpSpPr>
+      <p:grpSp>
+        <p:nvGrpSpPr>
+          <p:cNvPr id="25" name="Grupo 24">
+            <a:extLst>
+              <a:ext uri="{FF2B5EF4-FFF2-40B4-BE49-F238E27FC236}">
+                <a16:creationId xmlns:a16="http://schemas.microsoft.com/office/drawing/2014/main" id="{0D85F9DF-2EF3-DAE1-E3A7-3F4F4AE92497}"/>
+              </a:ext>
+            </a:extLst>
+          </p:cNvPr>
+          <p:cNvGrpSpPr/>
+          <p:nvPr/>
+        </p:nvGrpSpPr>
+        <p:grpSpPr>
+          <a:xfrm>
+            <a:off x="841727" y="546930"/>
+            <a:ext cx="2880000" cy="540000"/>
+            <a:chOff x="786213" y="521293"/>
+            <a:chExt cx="2880000" cy="540000"/>
+          </a:xfrm>
+        </p:grpSpPr>
+        <p:cxnSp>
+          <p:nvCxnSpPr>
+            <p:cNvPr id="10" name="Conector recto 9">
+              <a:extLst>
+                <a:ext uri="{FF2B5EF4-FFF2-40B4-BE49-F238E27FC236}">
+                  <a16:creationId xmlns:a16="http://schemas.microsoft.com/office/drawing/2014/main" id="{CB262ADA-C51A-7298-5621-D873B149376F}"/>
+                </a:ext>
+              </a:extLst>
+            </p:cNvPr>
+            <p:cNvCxnSpPr/>
+            <p:nvPr/>
+          </p:nvCxnSpPr>
+          <p:spPr>
+            <a:xfrm>
+              <a:off x="786213" y="521293"/>
+              <a:ext cx="0" cy="540000"/>
+            </a:xfrm>
+            <a:prstGeom prst="line">
+              <a:avLst/>
+            </a:prstGeom>
+          </p:spPr>
+          <p:style>
+            <a:lnRef idx="3">
+              <a:schemeClr val="accent2"/>
+            </a:lnRef>
+            <a:fillRef idx="0">
+              <a:schemeClr val="accent2"/>
+            </a:fillRef>
+            <a:effectRef idx="2">
+              <a:schemeClr val="accent2"/>
+            </a:effectRef>
+            <a:fontRef idx="minor">
+              <a:schemeClr val="tx1"/>
+            </a:fontRef>
+          </p:style>
+        </p:cxnSp>
+        <p:cxnSp>
+          <p:nvCxnSpPr>
+            <p:cNvPr id="14" name="Conector recto 13">
+              <a:extLst>
+                <a:ext uri="{FF2B5EF4-FFF2-40B4-BE49-F238E27FC236}">
+                  <a16:creationId xmlns:a16="http://schemas.microsoft.com/office/drawing/2014/main" id="{85370F90-7081-CD74-CA6A-C6B073C1B8D7}"/>
+                </a:ext>
+              </a:extLst>
+            </p:cNvPr>
+            <p:cNvCxnSpPr>
+              <a:cxnSpLocks/>
+            </p:cNvCxnSpPr>
+            <p:nvPr/>
+          </p:nvCxnSpPr>
+          <p:spPr>
+            <a:xfrm>
+              <a:off x="786213" y="1061293"/>
+              <a:ext cx="2880000" cy="0"/>
+            </a:xfrm>
+            <a:prstGeom prst="line">
+              <a:avLst/>
+            </a:prstGeom>
+          </p:spPr>
+          <p:style>
+            <a:lnRef idx="3">
+              <a:schemeClr val="accent2"/>
+            </a:lnRef>
+            <a:fillRef idx="0">
+              <a:schemeClr val="accent2"/>
+            </a:fillRef>
+            <a:effectRef idx="2">
+              <a:schemeClr val="accent2"/>
+            </a:effectRef>
+            <a:fontRef idx="minor">
+              <a:schemeClr val="tx1"/>
+            </a:fontRef>
+          </p:style>
+        </p:cxnSp>
+      </p:grpSp>
+      <p:sp>
+        <p:nvSpPr>
+          <p:cNvPr id="3" name="CuadroTexto 2">
+            <a:extLst>
+              <a:ext uri="{FF2B5EF4-FFF2-40B4-BE49-F238E27FC236}">
+                <a16:creationId xmlns:a16="http://schemas.microsoft.com/office/drawing/2014/main" id="{22D0628D-42D3-54A8-AC5D-97348A5BF44D}"/>
+              </a:ext>
+            </a:extLst>
+          </p:cNvPr>
+          <p:cNvSpPr txBox="1"/>
+          <p:nvPr/>
+        </p:nvSpPr>
+        <p:spPr>
+          <a:xfrm>
+            <a:off x="1031888" y="555724"/>
+            <a:ext cx="2499678" cy="369332"/>
+          </a:xfrm>
+          <a:prstGeom prst="rect">
+            <a:avLst/>
+          </a:prstGeom>
+          <a:noFill/>
+        </p:spPr>
+        <p:txBody>
+          <a:bodyPr wrap="square" rtlCol="0">
+            <a:spAutoFit/>
+          </a:bodyPr>
+          <a:lstStyle/>
+          <a:p>
+            <a:r>
+              <a:rPr lang="es-MX" dirty="0">
+                <a:solidFill>
+                  <a:schemeClr val="accent1"/>
+                </a:solidFill>
+                <a:latin typeface="+mj-lt"/>
+              </a:rPr>
+              <a:t>Mapa Tecnológico</a:t>
+            </a:r>
+            <a:endParaRPr lang="es-CL" dirty="0">
+              <a:solidFill>
+                <a:schemeClr val="accent1"/>
+              </a:solidFill>
+              <a:latin typeface="+mj-lt"/>
+            </a:endParaRPr>
+          </a:p>
+        </p:txBody>
+      </p:sp>
+    </p:spTree>
+    <p:extLst>
+      <p:ext uri="{BB962C8B-B14F-4D97-AF65-F5344CB8AC3E}">
+        <p14:creationId xmlns:p14="http://schemas.microsoft.com/office/powerpoint/2010/main" val="2462326697"/>
+      </p:ext>
+    </p:extLst>
+  </p:cSld>
+  <p:clrMapOvr>
+    <a:masterClrMapping/>
+  </p:clrMapOvr>
+</p:sld>
+</file>
+
+<file path=ppt/slides/slide9.xml><?xml version="1.0" encoding="utf-8"?>
+<p:sld xmlns:a="http://schemas.openxmlformats.org/drawingml/2006/main" xmlns:r="http://schemas.openxmlformats.org/officeDocument/2006/relationships" xmlns:p="http://schemas.openxmlformats.org/presentationml/2006/main">
+  <p:cSld>
+    <p:bg>
+      <p:bgPr>
+        <a:solidFill>
+          <a:schemeClr val="tx2"/>
+        </a:solidFill>
+        <a:effectLst/>
+      </p:bgPr>
+    </p:bg>
+    <p:spTree>
+      <p:nvGrpSpPr>
+        <p:cNvPr id="1" name="">
+          <a:extLst>
+            <a:ext uri="{FF2B5EF4-FFF2-40B4-BE49-F238E27FC236}">
+              <a16:creationId xmlns:a16="http://schemas.microsoft.com/office/drawing/2014/main" id="{551827A9-D0A6-68FD-56FF-EDF9A688F2A2}"/>
+            </a:ext>
+          </a:extLst>
+        </p:cNvPr>
+        <p:cNvGrpSpPr/>
+        <p:nvPr/>
+      </p:nvGrpSpPr>
+      <p:grpSpPr>
+        <a:xfrm>
+          <a:off x="0" y="0"/>
+          <a:ext cx="0" cy="0"/>
+          <a:chOff x="0" y="0"/>
+          <a:chExt cx="0" cy="0"/>
+        </a:xfrm>
+      </p:grpSpPr>
+      <p:sp>
+        <p:nvSpPr>
+          <p:cNvPr id="8" name="CuadroTexto 7">
+            <a:extLst>
+              <a:ext uri="{FF2B5EF4-FFF2-40B4-BE49-F238E27FC236}">
+                <a16:creationId xmlns:a16="http://schemas.microsoft.com/office/drawing/2014/main" id="{291A9698-138A-7EF7-D536-2E1DD2B84D6C}"/>
+              </a:ext>
+            </a:extLst>
+          </p:cNvPr>
+          <p:cNvSpPr txBox="1"/>
+          <p:nvPr/>
+        </p:nvSpPr>
+        <p:spPr>
+          <a:xfrm>
+            <a:off x="2281727" y="2264635"/>
+            <a:ext cx="4349810" cy="2346540"/>
+          </a:xfrm>
+          <a:prstGeom prst="rect">
+            <a:avLst/>
+          </a:prstGeom>
+          <a:noFill/>
+        </p:spPr>
+        <p:txBody>
+          <a:bodyPr wrap="square" rtlCol="0">
+            <a:spAutoFit/>
+          </a:bodyPr>
+          <a:lstStyle/>
+          <a:p>
+            <a:pPr marL="285750" indent="-285750">
+              <a:lnSpc>
+                <a:spcPct val="150000"/>
+              </a:lnSpc>
+              <a:buFont typeface="Arial" panose="020B0604020202020204" pitchFamily="34" charset="0"/>
+              <a:buChar char="•"/>
+            </a:pPr>
+            <a:r>
+              <a:rPr lang="es-MX" sz="2000" dirty="0" err="1">
+                <a:solidFill>
+                  <a:schemeClr val="bg1"/>
+                </a:solidFill>
+              </a:rPr>
+              <a:t>Saf</a:t>
+            </a:r>
+            <a:endParaRPr lang="es-MX" sz="2000" dirty="0">
+              <a:solidFill>
+                <a:schemeClr val="bg1"/>
+              </a:solidFill>
+            </a:endParaRPr>
+          </a:p>
+          <a:p>
+            <a:pPr marL="285750" indent="-285750">
+              <a:lnSpc>
+                <a:spcPct val="150000"/>
+              </a:lnSpc>
+              <a:buFont typeface="Arial" panose="020B0604020202020204" pitchFamily="34" charset="0"/>
+              <a:buChar char="•"/>
+            </a:pPr>
+            <a:endParaRPr lang="es-CL" sz="2000" dirty="0">
+              <a:solidFill>
+                <a:schemeClr val="bg1"/>
+              </a:solidFill>
+            </a:endParaRPr>
+          </a:p>
+          <a:p>
+            <a:pPr marL="285750" indent="-285750">
+              <a:lnSpc>
+                <a:spcPct val="150000"/>
+              </a:lnSpc>
+              <a:buFont typeface="Arial" panose="020B0604020202020204" pitchFamily="34" charset="0"/>
+              <a:buChar char="•"/>
+            </a:pPr>
+            <a:r>
+              <a:rPr lang="es-CL" sz="2000" dirty="0">
+                <a:solidFill>
+                  <a:schemeClr val="bg1"/>
+                </a:solidFill>
+              </a:rPr>
+              <a:t>S</a:t>
+            </a:r>
+          </a:p>
+          <a:p>
+            <a:pPr marL="285750" indent="-285750">
+              <a:lnSpc>
+                <a:spcPct val="150000"/>
+              </a:lnSpc>
+              <a:buFont typeface="Arial" panose="020B0604020202020204" pitchFamily="34" charset="0"/>
+              <a:buChar char="•"/>
+            </a:pPr>
+            <a:endParaRPr lang="es-CL" sz="2000" dirty="0">
+              <a:solidFill>
+                <a:schemeClr val="bg1"/>
+              </a:solidFill>
+            </a:endParaRPr>
+          </a:p>
+          <a:p>
+            <a:pPr marL="285750" indent="-285750">
+              <a:lnSpc>
+                <a:spcPct val="150000"/>
+              </a:lnSpc>
+              <a:buFont typeface="Arial" panose="020B0604020202020204" pitchFamily="34" charset="0"/>
+              <a:buChar char="•"/>
+            </a:pPr>
+            <a:r>
+              <a:rPr lang="es-CL" sz="2000" dirty="0">
+                <a:solidFill>
+                  <a:schemeClr val="bg1"/>
+                </a:solidFill>
+              </a:rPr>
+              <a:t>s</a:t>
+            </a:r>
+            <a:endParaRPr lang="es-MX" sz="2000" dirty="0">
+              <a:solidFill>
+                <a:schemeClr val="bg1"/>
+              </a:solidFill>
+            </a:endParaRPr>
+          </a:p>
+        </p:txBody>
+      </p:sp>
+      <p:grpSp>
+        <p:nvGrpSpPr>
+          <p:cNvPr id="25" name="Grupo 24">
+            <a:extLst>
+              <a:ext uri="{FF2B5EF4-FFF2-40B4-BE49-F238E27FC236}">
+                <a16:creationId xmlns:a16="http://schemas.microsoft.com/office/drawing/2014/main" id="{390B5309-AFE7-FC5D-3943-045FF3DC6525}"/>
+              </a:ext>
+            </a:extLst>
+          </p:cNvPr>
+          <p:cNvGrpSpPr/>
+          <p:nvPr/>
+        </p:nvGrpSpPr>
+        <p:grpSpPr>
+          <a:xfrm>
+            <a:off x="841727" y="546930"/>
+            <a:ext cx="2880000" cy="540000"/>
+            <a:chOff x="786213" y="521293"/>
+            <a:chExt cx="2880000" cy="540000"/>
+          </a:xfrm>
+        </p:grpSpPr>
+        <p:cxnSp>
+          <p:nvCxnSpPr>
+            <p:cNvPr id="10" name="Conector recto 9">
+              <a:extLst>
+                <a:ext uri="{FF2B5EF4-FFF2-40B4-BE49-F238E27FC236}">
+                  <a16:creationId xmlns:a16="http://schemas.microsoft.com/office/drawing/2014/main" id="{D49C6877-7C02-A0B1-6852-A782D0833B94}"/>
+                </a:ext>
+              </a:extLst>
+            </p:cNvPr>
+            <p:cNvCxnSpPr/>
+            <p:nvPr/>
+          </p:nvCxnSpPr>
+          <p:spPr>
+            <a:xfrm>
+              <a:off x="786213" y="521293"/>
+              <a:ext cx="0" cy="540000"/>
+            </a:xfrm>
+            <a:prstGeom prst="line">
+              <a:avLst/>
+            </a:prstGeom>
+          </p:spPr>
+          <p:style>
+            <a:lnRef idx="3">
+              <a:schemeClr val="accent2"/>
+            </a:lnRef>
+            <a:fillRef idx="0">
+              <a:schemeClr val="accent2"/>
+            </a:fillRef>
+            <a:effectRef idx="2">
+              <a:schemeClr val="accent2"/>
+            </a:effectRef>
+            <a:fontRef idx="minor">
+              <a:schemeClr val="tx1"/>
+            </a:fontRef>
+          </p:style>
+        </p:cxnSp>
+        <p:cxnSp>
+          <p:nvCxnSpPr>
+            <p:cNvPr id="14" name="Conector recto 13">
+              <a:extLst>
+                <a:ext uri="{FF2B5EF4-FFF2-40B4-BE49-F238E27FC236}">
+                  <a16:creationId xmlns:a16="http://schemas.microsoft.com/office/drawing/2014/main" id="{C3521BD6-4204-0E71-F755-DBBAB6CCE063}"/>
+                </a:ext>
+              </a:extLst>
+            </p:cNvPr>
+            <p:cNvCxnSpPr>
+              <a:cxnSpLocks/>
+            </p:cNvCxnSpPr>
+            <p:nvPr/>
+          </p:nvCxnSpPr>
+          <p:spPr>
+            <a:xfrm>
+              <a:off x="786213" y="1061293"/>
+              <a:ext cx="2880000" cy="0"/>
+            </a:xfrm>
+            <a:prstGeom prst="line">
+              <a:avLst/>
+            </a:prstGeom>
+          </p:spPr>
+          <p:style>
+            <a:lnRef idx="3">
+              <a:schemeClr val="accent2"/>
+            </a:lnRef>
+            <a:fillRef idx="0">
+              <a:schemeClr val="accent2"/>
+            </a:fillRef>
+            <a:effectRef idx="2">
+              <a:schemeClr val="accent2"/>
+            </a:effectRef>
+            <a:fontRef idx="minor">
+              <a:schemeClr val="tx1"/>
+            </a:fontRef>
+          </p:style>
+        </p:cxnSp>
+      </p:grpSp>
+      <p:sp>
+        <p:nvSpPr>
+          <p:cNvPr id="3" name="CuadroTexto 2">
+            <a:extLst>
+              <a:ext uri="{FF2B5EF4-FFF2-40B4-BE49-F238E27FC236}">
+                <a16:creationId xmlns:a16="http://schemas.microsoft.com/office/drawing/2014/main" id="{9666F5D7-0D7C-5AA5-C7DD-4D7A07ACF763}"/>
+              </a:ext>
+            </a:extLst>
+          </p:cNvPr>
+          <p:cNvSpPr txBox="1"/>
+          <p:nvPr/>
+        </p:nvSpPr>
+        <p:spPr>
+          <a:xfrm>
+            <a:off x="1031888" y="555724"/>
+            <a:ext cx="2499678" cy="369332"/>
+          </a:xfrm>
+          <a:prstGeom prst="rect">
+            <a:avLst/>
+          </a:prstGeom>
+          <a:noFill/>
+        </p:spPr>
+        <p:txBody>
+          <a:bodyPr wrap="square" rtlCol="0">
+            <a:spAutoFit/>
+          </a:bodyPr>
+          <a:lstStyle/>
+          <a:p>
+            <a:r>
+              <a:rPr lang="es-MX" dirty="0">
+                <a:solidFill>
+                  <a:schemeClr val="accent1"/>
+                </a:solidFill>
+                <a:latin typeface="+mj-lt"/>
+              </a:rPr>
+              <a:t>Seguridad</a:t>
+            </a:r>
+            <a:endParaRPr lang="es-CL" dirty="0">
+              <a:solidFill>
+                <a:schemeClr val="accent1"/>
+              </a:solidFill>
+              <a:latin typeface="+mj-lt"/>
+            </a:endParaRPr>
+          </a:p>
+        </p:txBody>
+      </p:sp>
+    </p:spTree>
+    <p:extLst>
+      <p:ext uri="{BB962C8B-B14F-4D97-AF65-F5344CB8AC3E}">
+        <p14:creationId xmlns:p14="http://schemas.microsoft.com/office/powerpoint/2010/main" val="1575871677"/>
       </p:ext>
     </p:extLst>
   </p:cSld>

</xml_diff>